<commit_message>
add clear screen function
</commit_message>
<xml_diff>
--- a/LISTEN/2_22_12.pptx
+++ b/LISTEN/2_22_12.pptx
@@ -241,7 +241,7 @@
           <a:p>
             <a:fld id="{D997B5FA-0921-464F-AAE1-844C04324D75}" type="datetimeFigureOut">
               <a:rPr lang="zh-CN" altLang="en-US" smtClean="0"/>
-              <a:t>2025/6/22/Sunday</a:t>
+              <a:t>2025/9/22/Monday</a:t>
             </a:fld>
             <a:endParaRPr lang="zh-CN" altLang="en-US"/>
           </a:p>
@@ -404,7 +404,7 @@
           <a:p>
             <a:fld id="{D997B5FA-0921-464F-AAE1-844C04324D75}" type="datetimeFigureOut">
               <a:rPr lang="zh-CN" altLang="en-US" smtClean="0"/>
-              <a:t>2025/6/22/Sunday</a:t>
+              <a:t>2025/9/22/Monday</a:t>
             </a:fld>
             <a:endParaRPr lang="zh-CN" altLang="en-US"/>
           </a:p>
@@ -577,7 +577,7 @@
           <a:p>
             <a:fld id="{D997B5FA-0921-464F-AAE1-844C04324D75}" type="datetimeFigureOut">
               <a:rPr lang="zh-CN" altLang="en-US" smtClean="0"/>
-              <a:t>2025/6/22/Sunday</a:t>
+              <a:t>2025/9/22/Monday</a:t>
             </a:fld>
             <a:endParaRPr lang="zh-CN" altLang="en-US"/>
           </a:p>
@@ -740,7 +740,7 @@
           <a:p>
             <a:fld id="{D997B5FA-0921-464F-AAE1-844C04324D75}" type="datetimeFigureOut">
               <a:rPr lang="zh-CN" altLang="en-US" smtClean="0"/>
-              <a:t>2025/6/22/Sunday</a:t>
+              <a:t>2025/9/22/Monday</a:t>
             </a:fld>
             <a:endParaRPr lang="zh-CN" altLang="en-US"/>
           </a:p>
@@ -980,7 +980,7 @@
           <a:p>
             <a:fld id="{D997B5FA-0921-464F-AAE1-844C04324D75}" type="datetimeFigureOut">
               <a:rPr lang="zh-CN" altLang="en-US" smtClean="0"/>
-              <a:t>2025/6/22/Sunday</a:t>
+              <a:t>2025/9/22/Monday</a:t>
             </a:fld>
             <a:endParaRPr lang="zh-CN" altLang="en-US"/>
           </a:p>
@@ -1204,7 +1204,7 @@
           <a:p>
             <a:fld id="{D997B5FA-0921-464F-AAE1-844C04324D75}" type="datetimeFigureOut">
               <a:rPr lang="zh-CN" altLang="en-US" smtClean="0"/>
-              <a:t>2025/6/22/Sunday</a:t>
+              <a:t>2025/9/22/Monday</a:t>
             </a:fld>
             <a:endParaRPr lang="zh-CN" altLang="en-US"/>
           </a:p>
@@ -1563,7 +1563,7 @@
           <a:p>
             <a:fld id="{D997B5FA-0921-464F-AAE1-844C04324D75}" type="datetimeFigureOut">
               <a:rPr lang="zh-CN" altLang="en-US" smtClean="0"/>
-              <a:t>2025/6/22/Sunday</a:t>
+              <a:t>2025/9/22/Monday</a:t>
             </a:fld>
             <a:endParaRPr lang="zh-CN" altLang="en-US"/>
           </a:p>
@@ -1675,7 +1675,7 @@
           <a:p>
             <a:fld id="{D997B5FA-0921-464F-AAE1-844C04324D75}" type="datetimeFigureOut">
               <a:rPr lang="zh-CN" altLang="en-US" smtClean="0"/>
-              <a:t>2025/6/22/Sunday</a:t>
+              <a:t>2025/9/22/Monday</a:t>
             </a:fld>
             <a:endParaRPr lang="zh-CN" altLang="en-US"/>
           </a:p>
@@ -1765,7 +1765,7 @@
           <a:p>
             <a:fld id="{D997B5FA-0921-464F-AAE1-844C04324D75}" type="datetimeFigureOut">
               <a:rPr lang="zh-CN" altLang="en-US" smtClean="0"/>
-              <a:t>2025/6/22/Sunday</a:t>
+              <a:t>2025/9/22/Monday</a:t>
             </a:fld>
             <a:endParaRPr lang="zh-CN" altLang="en-US"/>
           </a:p>
@@ -2035,7 +2035,7 @@
           <a:p>
             <a:fld id="{D997B5FA-0921-464F-AAE1-844C04324D75}" type="datetimeFigureOut">
               <a:rPr lang="zh-CN" altLang="en-US" smtClean="0"/>
-              <a:t>2025/6/22/Sunday</a:t>
+              <a:t>2025/9/22/Monday</a:t>
             </a:fld>
             <a:endParaRPr lang="zh-CN" altLang="en-US"/>
           </a:p>
@@ -2282,7 +2282,7 @@
           <a:p>
             <a:fld id="{D997B5FA-0921-464F-AAE1-844C04324D75}" type="datetimeFigureOut">
               <a:rPr lang="zh-CN" altLang="en-US" smtClean="0"/>
-              <a:t>2025/6/22/Sunday</a:t>
+              <a:t>2025/9/22/Monday</a:t>
             </a:fld>
             <a:endParaRPr lang="zh-CN" altLang="en-US"/>
           </a:p>
@@ -2488,7 +2488,7 @@
           <a:p>
             <a:fld id="{D997B5FA-0921-464F-AAE1-844C04324D75}" type="datetimeFigureOut">
               <a:rPr lang="zh-CN" altLang="en-US" smtClean="0"/>
-              <a:t>2025/6/22/Sunday</a:t>
+              <a:t>2025/9/22/Monday</a:t>
             </a:fld>
             <a:endParaRPr lang="zh-CN" altLang="en-US"/>
           </a:p>

</xml_diff>

<commit_message>
update listening 22_12 -> 1_1 and 1_2
</commit_message>
<xml_diff>
--- a/LISTEN/2_22_12.pptx
+++ b/LISTEN/2_22_12.pptx
@@ -6,6 +6,7 @@
   </p:sldMasterIdLst>
   <p:sldIdLst>
     <p:sldId id="257" r:id="rId2"/>
+    <p:sldId id="258" r:id="rId3"/>
   </p:sldIdLst>
   <p:sldSz cx="12192000" cy="6858000"/>
   <p:notesSz cx="6858000" cy="9144000"/>
@@ -241,7 +242,7 @@
           <a:p>
             <a:fld id="{D997B5FA-0921-464F-AAE1-844C04324D75}" type="datetimeFigureOut">
               <a:rPr lang="zh-CN" altLang="en-US" smtClean="0"/>
-              <a:t>2025/9/22/Monday</a:t>
+              <a:t>2025/9/24/Wednesday</a:t>
             </a:fld>
             <a:endParaRPr lang="zh-CN" altLang="en-US"/>
           </a:p>
@@ -404,7 +405,7 @@
           <a:p>
             <a:fld id="{D997B5FA-0921-464F-AAE1-844C04324D75}" type="datetimeFigureOut">
               <a:rPr lang="zh-CN" altLang="en-US" smtClean="0"/>
-              <a:t>2025/9/22/Monday</a:t>
+              <a:t>2025/9/24/Wednesday</a:t>
             </a:fld>
             <a:endParaRPr lang="zh-CN" altLang="en-US"/>
           </a:p>
@@ -577,7 +578,7 @@
           <a:p>
             <a:fld id="{D997B5FA-0921-464F-AAE1-844C04324D75}" type="datetimeFigureOut">
               <a:rPr lang="zh-CN" altLang="en-US" smtClean="0"/>
-              <a:t>2025/9/22/Monday</a:t>
+              <a:t>2025/9/24/Wednesday</a:t>
             </a:fld>
             <a:endParaRPr lang="zh-CN" altLang="en-US"/>
           </a:p>
@@ -740,7 +741,7 @@
           <a:p>
             <a:fld id="{D997B5FA-0921-464F-AAE1-844C04324D75}" type="datetimeFigureOut">
               <a:rPr lang="zh-CN" altLang="en-US" smtClean="0"/>
-              <a:t>2025/9/22/Monday</a:t>
+              <a:t>2025/9/24/Wednesday</a:t>
             </a:fld>
             <a:endParaRPr lang="zh-CN" altLang="en-US"/>
           </a:p>
@@ -980,7 +981,7 @@
           <a:p>
             <a:fld id="{D997B5FA-0921-464F-AAE1-844C04324D75}" type="datetimeFigureOut">
               <a:rPr lang="zh-CN" altLang="en-US" smtClean="0"/>
-              <a:t>2025/9/22/Monday</a:t>
+              <a:t>2025/9/24/Wednesday</a:t>
             </a:fld>
             <a:endParaRPr lang="zh-CN" altLang="en-US"/>
           </a:p>
@@ -1204,7 +1205,7 @@
           <a:p>
             <a:fld id="{D997B5FA-0921-464F-AAE1-844C04324D75}" type="datetimeFigureOut">
               <a:rPr lang="zh-CN" altLang="en-US" smtClean="0"/>
-              <a:t>2025/9/22/Monday</a:t>
+              <a:t>2025/9/24/Wednesday</a:t>
             </a:fld>
             <a:endParaRPr lang="zh-CN" altLang="en-US"/>
           </a:p>
@@ -1563,7 +1564,7 @@
           <a:p>
             <a:fld id="{D997B5FA-0921-464F-AAE1-844C04324D75}" type="datetimeFigureOut">
               <a:rPr lang="zh-CN" altLang="en-US" smtClean="0"/>
-              <a:t>2025/9/22/Monday</a:t>
+              <a:t>2025/9/24/Wednesday</a:t>
             </a:fld>
             <a:endParaRPr lang="zh-CN" altLang="en-US"/>
           </a:p>
@@ -1675,7 +1676,7 @@
           <a:p>
             <a:fld id="{D997B5FA-0921-464F-AAE1-844C04324D75}" type="datetimeFigureOut">
               <a:rPr lang="zh-CN" altLang="en-US" smtClean="0"/>
-              <a:t>2025/9/22/Monday</a:t>
+              <a:t>2025/9/24/Wednesday</a:t>
             </a:fld>
             <a:endParaRPr lang="zh-CN" altLang="en-US"/>
           </a:p>
@@ -1765,7 +1766,7 @@
           <a:p>
             <a:fld id="{D997B5FA-0921-464F-AAE1-844C04324D75}" type="datetimeFigureOut">
               <a:rPr lang="zh-CN" altLang="en-US" smtClean="0"/>
-              <a:t>2025/9/22/Monday</a:t>
+              <a:t>2025/9/24/Wednesday</a:t>
             </a:fld>
             <a:endParaRPr lang="zh-CN" altLang="en-US"/>
           </a:p>
@@ -2035,7 +2036,7 @@
           <a:p>
             <a:fld id="{D997B5FA-0921-464F-AAE1-844C04324D75}" type="datetimeFigureOut">
               <a:rPr lang="zh-CN" altLang="en-US" smtClean="0"/>
-              <a:t>2025/9/22/Monday</a:t>
+              <a:t>2025/9/24/Wednesday</a:t>
             </a:fld>
             <a:endParaRPr lang="zh-CN" altLang="en-US"/>
           </a:p>
@@ -2282,7 +2283,7 @@
           <a:p>
             <a:fld id="{D997B5FA-0921-464F-AAE1-844C04324D75}" type="datetimeFigureOut">
               <a:rPr lang="zh-CN" altLang="en-US" smtClean="0"/>
-              <a:t>2025/9/22/Monday</a:t>
+              <a:t>2025/9/24/Wednesday</a:t>
             </a:fld>
             <a:endParaRPr lang="zh-CN" altLang="en-US"/>
           </a:p>
@@ -2488,7 +2489,7 @@
           <a:p>
             <a:fld id="{D997B5FA-0921-464F-AAE1-844C04324D75}" type="datetimeFigureOut">
               <a:rPr lang="zh-CN" altLang="en-US" smtClean="0"/>
-              <a:t>2025/9/22/Monday</a:t>
+              <a:t>2025/9/24/Wednesday</a:t>
             </a:fld>
             <a:endParaRPr lang="zh-CN" altLang="en-US"/>
           </a:p>
@@ -3028,8 +3029,8 @@
         </p:nvSpPr>
         <p:spPr>
           <a:xfrm>
-            <a:off x="5802921" y="657198"/>
-            <a:ext cx="1348154" cy="276999"/>
+            <a:off x="5802920" y="657198"/>
+            <a:ext cx="1014047" cy="276999"/>
           </a:xfrm>
           <a:prstGeom prst="rect">
             <a:avLst/>
@@ -4233,6 +4234,778 @@
         </p:txBody>
       </p:sp>
     </p:spTree>
+  </p:cSld>
+  <p:clrMapOvr>
+    <a:masterClrMapping/>
+  </p:clrMapOvr>
+</p:sld>
+</file>
+
+<file path=ppt/slides/slide2.xml><?xml version="1.0" encoding="utf-8"?>
+<p:sld xmlns:a="http://schemas.openxmlformats.org/drawingml/2006/main" xmlns:r="http://schemas.openxmlformats.org/officeDocument/2006/relationships" xmlns:p="http://schemas.openxmlformats.org/presentationml/2006/main">
+  <p:cSld>
+    <p:spTree>
+      <p:nvGrpSpPr>
+        <p:cNvPr id="1" name=""/>
+        <p:cNvGrpSpPr/>
+        <p:nvPr/>
+      </p:nvGrpSpPr>
+      <p:grpSpPr>
+        <a:xfrm>
+          <a:off x="0" y="0"/>
+          <a:ext cx="0" cy="0"/>
+          <a:chOff x="0" y="0"/>
+          <a:chExt cx="0" cy="0"/>
+        </a:xfrm>
+      </p:grpSpPr>
+      <p:pic>
+        <p:nvPicPr>
+          <p:cNvPr id="4" name="图片 3">
+            <a:extLst>
+              <a:ext uri="{FF2B5EF4-FFF2-40B4-BE49-F238E27FC236}">
+                <a16:creationId xmlns:a16="http://schemas.microsoft.com/office/drawing/2014/main" id="{0D18D972-5C17-4F57-A03F-C1E3271F9C78}"/>
+              </a:ext>
+            </a:extLst>
+          </p:cNvPr>
+          <p:cNvPicPr>
+            <a:picLocks noChangeAspect="1"/>
+          </p:cNvPicPr>
+          <p:nvPr/>
+        </p:nvPicPr>
+        <p:blipFill>
+          <a:blip r:embed="rId2"/>
+          <a:stretch>
+            <a:fillRect/>
+          </a:stretch>
+        </p:blipFill>
+        <p:spPr>
+          <a:xfrm>
+            <a:off x="72461" y="524277"/>
+            <a:ext cx="12047077" cy="5809446"/>
+          </a:xfrm>
+          <a:prstGeom prst="rect">
+            <a:avLst/>
+          </a:prstGeom>
+        </p:spPr>
+      </p:pic>
+      <p:sp>
+        <p:nvSpPr>
+          <p:cNvPr id="6" name="文本框 5">
+            <a:extLst>
+              <a:ext uri="{FF2B5EF4-FFF2-40B4-BE49-F238E27FC236}">
+                <a16:creationId xmlns:a16="http://schemas.microsoft.com/office/drawing/2014/main" id="{857F40DE-9223-478E-9465-E20AD1B3C1C1}"/>
+              </a:ext>
+            </a:extLst>
+          </p:cNvPr>
+          <p:cNvSpPr txBox="1"/>
+          <p:nvPr/>
+        </p:nvSpPr>
+        <p:spPr>
+          <a:xfrm>
+            <a:off x="-98351" y="3201802"/>
+            <a:ext cx="1002119" cy="369332"/>
+          </a:xfrm>
+          <a:prstGeom prst="rect">
+            <a:avLst/>
+          </a:prstGeom>
+          <a:noFill/>
+        </p:spPr>
+        <p:txBody>
+          <a:bodyPr wrap="square">
+            <a:spAutoFit/>
+          </a:bodyPr>
+          <a:lstStyle/>
+          <a:p>
+            <a:r>
+              <a:rPr lang="zh-CN" altLang="en-US" dirty="0">
+                <a:solidFill>
+                  <a:schemeClr val="accent1"/>
+                </a:solidFill>
+              </a:rPr>
+              <a:t>ちいき</a:t>
+            </a:r>
+          </a:p>
+        </p:txBody>
+      </p:sp>
+      <p:sp>
+        <p:nvSpPr>
+          <p:cNvPr id="8" name="文本框 7">
+            <a:extLst>
+              <a:ext uri="{FF2B5EF4-FFF2-40B4-BE49-F238E27FC236}">
+                <a16:creationId xmlns:a16="http://schemas.microsoft.com/office/drawing/2014/main" id="{569545DD-6E31-4515-A80C-EFAB079499AA}"/>
+              </a:ext>
+            </a:extLst>
+          </p:cNvPr>
+          <p:cNvSpPr txBox="1"/>
+          <p:nvPr/>
+        </p:nvSpPr>
+        <p:spPr>
+          <a:xfrm>
+            <a:off x="587449" y="3200398"/>
+            <a:ext cx="1156291" cy="369332"/>
+          </a:xfrm>
+          <a:prstGeom prst="rect">
+            <a:avLst/>
+          </a:prstGeom>
+          <a:noFill/>
+        </p:spPr>
+        <p:txBody>
+          <a:bodyPr wrap="square">
+            <a:spAutoFit/>
+          </a:bodyPr>
+          <a:lstStyle/>
+          <a:p>
+            <a:r>
+              <a:rPr lang="zh-CN" altLang="en-US">
+                <a:solidFill>
+                  <a:schemeClr val="accent1"/>
+                </a:solidFill>
+              </a:rPr>
+              <a:t>いけばな</a:t>
+            </a:r>
+            <a:endParaRPr lang="zh-CN" altLang="en-US" dirty="0">
+              <a:solidFill>
+                <a:schemeClr val="accent1"/>
+              </a:solidFill>
+            </a:endParaRPr>
+          </a:p>
+        </p:txBody>
+      </p:sp>
+      <p:sp>
+        <p:nvSpPr>
+          <p:cNvPr id="10" name="文本框 9">
+            <a:extLst>
+              <a:ext uri="{FF2B5EF4-FFF2-40B4-BE49-F238E27FC236}">
+                <a16:creationId xmlns:a16="http://schemas.microsoft.com/office/drawing/2014/main" id="{8B956DC3-C3FA-4F46-B6DB-A28BBFB25B43}"/>
+              </a:ext>
+            </a:extLst>
+          </p:cNvPr>
+          <p:cNvSpPr txBox="1"/>
+          <p:nvPr/>
+        </p:nvSpPr>
+        <p:spPr>
+          <a:xfrm>
+            <a:off x="2937244" y="3244334"/>
+            <a:ext cx="699091" cy="369332"/>
+          </a:xfrm>
+          <a:prstGeom prst="rect">
+            <a:avLst/>
+          </a:prstGeom>
+          <a:noFill/>
+        </p:spPr>
+        <p:txBody>
+          <a:bodyPr wrap="square">
+            <a:spAutoFit/>
+          </a:bodyPr>
+          <a:lstStyle/>
+          <a:p>
+            <a:r>
+              <a:rPr lang="zh-CN" altLang="en-US" dirty="0">
+                <a:solidFill>
+                  <a:schemeClr val="accent1"/>
+                </a:solidFill>
+              </a:rPr>
+              <a:t>るす</a:t>
+            </a:r>
+          </a:p>
+        </p:txBody>
+      </p:sp>
+      <p:sp>
+        <p:nvSpPr>
+          <p:cNvPr id="12" name="文本框 11">
+            <a:extLst>
+              <a:ext uri="{FF2B5EF4-FFF2-40B4-BE49-F238E27FC236}">
+                <a16:creationId xmlns:a16="http://schemas.microsoft.com/office/drawing/2014/main" id="{BF7D9310-A80F-49B6-A0A5-1205C1D9AE64}"/>
+              </a:ext>
+            </a:extLst>
+          </p:cNvPr>
+          <p:cNvSpPr txBox="1"/>
+          <p:nvPr/>
+        </p:nvSpPr>
+        <p:spPr>
+          <a:xfrm>
+            <a:off x="7562406" y="3839756"/>
+            <a:ext cx="1634756" cy="369332"/>
+          </a:xfrm>
+          <a:prstGeom prst="rect">
+            <a:avLst/>
+          </a:prstGeom>
+          <a:noFill/>
+        </p:spPr>
+        <p:txBody>
+          <a:bodyPr wrap="square">
+            <a:spAutoFit/>
+          </a:bodyPr>
+          <a:lstStyle/>
+          <a:p>
+            <a:r>
+              <a:rPr lang="zh-CN" altLang="en-US" dirty="0">
+                <a:solidFill>
+                  <a:schemeClr val="accent1"/>
+                </a:solidFill>
+              </a:rPr>
+              <a:t>てんらんかい</a:t>
+            </a:r>
+          </a:p>
+        </p:txBody>
+      </p:sp>
+      <p:sp>
+        <p:nvSpPr>
+          <p:cNvPr id="14" name="文本框 13">
+            <a:extLst>
+              <a:ext uri="{FF2B5EF4-FFF2-40B4-BE49-F238E27FC236}">
+                <a16:creationId xmlns:a16="http://schemas.microsoft.com/office/drawing/2014/main" id="{2C99FAE8-7C17-4A26-B9E1-5702DDFED05E}"/>
+              </a:ext>
+            </a:extLst>
+          </p:cNvPr>
+          <p:cNvSpPr txBox="1"/>
+          <p:nvPr/>
+        </p:nvSpPr>
+        <p:spPr>
+          <a:xfrm>
+            <a:off x="9656230" y="3806455"/>
+            <a:ext cx="1002119" cy="369332"/>
+          </a:xfrm>
+          <a:prstGeom prst="rect">
+            <a:avLst/>
+          </a:prstGeom>
+          <a:noFill/>
+        </p:spPr>
+        <p:txBody>
+          <a:bodyPr wrap="square">
+            <a:spAutoFit/>
+          </a:bodyPr>
+          <a:lstStyle/>
+          <a:p>
+            <a:r>
+              <a:rPr lang="zh-CN" altLang="en-US" dirty="0">
+                <a:solidFill>
+                  <a:schemeClr val="accent1"/>
+                </a:solidFill>
+              </a:rPr>
+              <a:t>文件</a:t>
+            </a:r>
+          </a:p>
+        </p:txBody>
+      </p:sp>
+      <p:sp>
+        <p:nvSpPr>
+          <p:cNvPr id="16" name="文本框 15">
+            <a:extLst>
+              <a:ext uri="{FF2B5EF4-FFF2-40B4-BE49-F238E27FC236}">
+                <a16:creationId xmlns:a16="http://schemas.microsoft.com/office/drawing/2014/main" id="{157A8352-B13E-42BB-BB03-B8F2821D067D}"/>
+              </a:ext>
+            </a:extLst>
+          </p:cNvPr>
+          <p:cNvSpPr txBox="1"/>
+          <p:nvPr/>
+        </p:nvSpPr>
+        <p:spPr>
+          <a:xfrm>
+            <a:off x="11189882" y="3885922"/>
+            <a:ext cx="1002118" cy="276999"/>
+          </a:xfrm>
+          <a:prstGeom prst="rect">
+            <a:avLst/>
+          </a:prstGeom>
+          <a:noFill/>
+        </p:spPr>
+        <p:txBody>
+          <a:bodyPr wrap="square">
+            <a:spAutoFit/>
+          </a:bodyPr>
+          <a:lstStyle/>
+          <a:p>
+            <a:r>
+              <a:rPr lang="zh-CN" altLang="en-US" sz="1200" dirty="0">
+                <a:solidFill>
+                  <a:schemeClr val="accent1"/>
+                </a:solidFill>
+              </a:rPr>
+              <a:t>かいじょう</a:t>
+            </a:r>
+          </a:p>
+        </p:txBody>
+      </p:sp>
+      <p:sp>
+        <p:nvSpPr>
+          <p:cNvPr id="18" name="文本框 17">
+            <a:extLst>
+              <a:ext uri="{FF2B5EF4-FFF2-40B4-BE49-F238E27FC236}">
+                <a16:creationId xmlns:a16="http://schemas.microsoft.com/office/drawing/2014/main" id="{7C4FEFA7-AEAC-412A-BA7C-E2BCB7102033}"/>
+              </a:ext>
+            </a:extLst>
+          </p:cNvPr>
+          <p:cNvSpPr txBox="1"/>
+          <p:nvPr/>
+        </p:nvSpPr>
+        <p:spPr>
+          <a:xfrm>
+            <a:off x="51168" y="4496631"/>
+            <a:ext cx="703079" cy="369332"/>
+          </a:xfrm>
+          <a:prstGeom prst="rect">
+            <a:avLst/>
+          </a:prstGeom>
+          <a:noFill/>
+        </p:spPr>
+        <p:txBody>
+          <a:bodyPr wrap="square">
+            <a:spAutoFit/>
+          </a:bodyPr>
+          <a:lstStyle/>
+          <a:p>
+            <a:r>
+              <a:rPr lang="zh-CN" altLang="en-US" dirty="0">
+                <a:solidFill>
+                  <a:schemeClr val="accent1"/>
+                </a:solidFill>
+              </a:rPr>
+              <a:t>标题</a:t>
+            </a:r>
+          </a:p>
+        </p:txBody>
+      </p:sp>
+      <p:sp>
+        <p:nvSpPr>
+          <p:cNvPr id="20" name="文本框 19">
+            <a:extLst>
+              <a:ext uri="{FF2B5EF4-FFF2-40B4-BE49-F238E27FC236}">
+                <a16:creationId xmlns:a16="http://schemas.microsoft.com/office/drawing/2014/main" id="{7CE7CC5F-DB33-4A29-A566-A6A22B7E922F}"/>
+              </a:ext>
+            </a:extLst>
+          </p:cNvPr>
+          <p:cNvSpPr txBox="1"/>
+          <p:nvPr/>
+        </p:nvSpPr>
+        <p:spPr>
+          <a:xfrm>
+            <a:off x="775540" y="4496631"/>
+            <a:ext cx="703079" cy="369332"/>
+          </a:xfrm>
+          <a:prstGeom prst="rect">
+            <a:avLst/>
+          </a:prstGeom>
+          <a:noFill/>
+        </p:spPr>
+        <p:txBody>
+          <a:bodyPr wrap="square">
+            <a:spAutoFit/>
+          </a:bodyPr>
+          <a:lstStyle/>
+          <a:p>
+            <a:r>
+              <a:rPr lang="zh-CN" altLang="en-US" dirty="0">
+                <a:solidFill>
+                  <a:schemeClr val="accent1"/>
+                </a:solidFill>
+              </a:rPr>
+              <a:t>もじ</a:t>
+            </a:r>
+          </a:p>
+        </p:txBody>
+      </p:sp>
+      <p:sp>
+        <p:nvSpPr>
+          <p:cNvPr id="22" name="文本框 21">
+            <a:extLst>
+              <a:ext uri="{FF2B5EF4-FFF2-40B4-BE49-F238E27FC236}">
+                <a16:creationId xmlns:a16="http://schemas.microsoft.com/office/drawing/2014/main" id="{ADA0D15A-4657-4316-AB1C-A13B66DAB320}"/>
+              </a:ext>
+            </a:extLst>
+          </p:cNvPr>
+          <p:cNvSpPr txBox="1"/>
+          <p:nvPr/>
+        </p:nvSpPr>
+        <p:spPr>
+          <a:xfrm>
+            <a:off x="2897469" y="4496631"/>
+            <a:ext cx="1355554" cy="369332"/>
+          </a:xfrm>
+          <a:prstGeom prst="rect">
+            <a:avLst/>
+          </a:prstGeom>
+          <a:noFill/>
+        </p:spPr>
+        <p:txBody>
+          <a:bodyPr wrap="square">
+            <a:spAutoFit/>
+          </a:bodyPr>
+          <a:lstStyle/>
+          <a:p>
+            <a:r>
+              <a:rPr lang="zh-CN" altLang="en-US" dirty="0">
+                <a:solidFill>
+                  <a:schemeClr val="accent1"/>
+                </a:solidFill>
+              </a:rPr>
+              <a:t>ひとまわり</a:t>
+            </a:r>
+          </a:p>
+        </p:txBody>
+      </p:sp>
+      <p:sp>
+        <p:nvSpPr>
+          <p:cNvPr id="24" name="文本框 23">
+            <a:extLst>
+              <a:ext uri="{FF2B5EF4-FFF2-40B4-BE49-F238E27FC236}">
+                <a16:creationId xmlns:a16="http://schemas.microsoft.com/office/drawing/2014/main" id="{54152252-42CB-4449-9278-CF29ED37CD88}"/>
+              </a:ext>
+            </a:extLst>
+          </p:cNvPr>
+          <p:cNvSpPr txBox="1"/>
+          <p:nvPr/>
+        </p:nvSpPr>
+        <p:spPr>
+          <a:xfrm>
+            <a:off x="9799767" y="4496631"/>
+            <a:ext cx="784151" cy="369332"/>
+          </a:xfrm>
+          <a:prstGeom prst="rect">
+            <a:avLst/>
+          </a:prstGeom>
+          <a:noFill/>
+        </p:spPr>
+        <p:txBody>
+          <a:bodyPr wrap="square">
+            <a:spAutoFit/>
+          </a:bodyPr>
+          <a:lstStyle/>
+          <a:p>
+            <a:r>
+              <a:rPr lang="zh-CN" altLang="en-US" dirty="0">
+                <a:solidFill>
+                  <a:schemeClr val="accent1"/>
+                </a:solidFill>
+              </a:rPr>
+              <a:t>いち</a:t>
+            </a:r>
+          </a:p>
+        </p:txBody>
+      </p:sp>
+      <p:sp>
+        <p:nvSpPr>
+          <p:cNvPr id="26" name="文本框 25">
+            <a:extLst>
+              <a:ext uri="{FF2B5EF4-FFF2-40B4-BE49-F238E27FC236}">
+                <a16:creationId xmlns:a16="http://schemas.microsoft.com/office/drawing/2014/main" id="{AEB7BB73-04EA-40F5-AE9B-2EC004A018C4}"/>
+              </a:ext>
+            </a:extLst>
+          </p:cNvPr>
+          <p:cNvSpPr txBox="1"/>
+          <p:nvPr/>
+        </p:nvSpPr>
+        <p:spPr>
+          <a:xfrm>
+            <a:off x="10429354" y="4891856"/>
+            <a:ext cx="879844" cy="369332"/>
+          </a:xfrm>
+          <a:prstGeom prst="rect">
+            <a:avLst/>
+          </a:prstGeom>
+          <a:noFill/>
+        </p:spPr>
+        <p:txBody>
+          <a:bodyPr wrap="square">
+            <a:spAutoFit/>
+          </a:bodyPr>
+          <a:lstStyle/>
+          <a:p>
+            <a:r>
+              <a:rPr lang="zh-CN" altLang="en-US" dirty="0">
+                <a:solidFill>
+                  <a:schemeClr val="accent1"/>
+                </a:solidFill>
+              </a:rPr>
+              <a:t>少许</a:t>
+            </a:r>
+          </a:p>
+        </p:txBody>
+      </p:sp>
+      <p:sp>
+        <p:nvSpPr>
+          <p:cNvPr id="28" name="文本框 27">
+            <a:extLst>
+              <a:ext uri="{FF2B5EF4-FFF2-40B4-BE49-F238E27FC236}">
+                <a16:creationId xmlns:a16="http://schemas.microsoft.com/office/drawing/2014/main" id="{95577B7B-AE8F-4EED-8881-AF2C8A20AA36}"/>
+              </a:ext>
+            </a:extLst>
+          </p:cNvPr>
+          <p:cNvSpPr txBox="1"/>
+          <p:nvPr/>
+        </p:nvSpPr>
+        <p:spPr>
+          <a:xfrm>
+            <a:off x="10754730" y="4514522"/>
+            <a:ext cx="869212" cy="369332"/>
+          </a:xfrm>
+          <a:prstGeom prst="rect">
+            <a:avLst/>
+          </a:prstGeom>
+          <a:noFill/>
+        </p:spPr>
+        <p:txBody>
+          <a:bodyPr wrap="square">
+            <a:spAutoFit/>
+          </a:bodyPr>
+          <a:lstStyle/>
+          <a:p>
+            <a:r>
+              <a:rPr lang="zh-CN" altLang="en-US" dirty="0">
+                <a:solidFill>
+                  <a:schemeClr val="accent1"/>
+                </a:solidFill>
+              </a:rPr>
+              <a:t>ひだり</a:t>
+            </a:r>
+          </a:p>
+        </p:txBody>
+      </p:sp>
+      <p:sp>
+        <p:nvSpPr>
+          <p:cNvPr id="30" name="文本框 29">
+            <a:extLst>
+              <a:ext uri="{FF2B5EF4-FFF2-40B4-BE49-F238E27FC236}">
+                <a16:creationId xmlns:a16="http://schemas.microsoft.com/office/drawing/2014/main" id="{0ED52D73-2A2C-45F0-BBF3-68645EF0C733}"/>
+              </a:ext>
+            </a:extLst>
+          </p:cNvPr>
+          <p:cNvSpPr txBox="1"/>
+          <p:nvPr/>
+        </p:nvSpPr>
+        <p:spPr>
+          <a:xfrm>
+            <a:off x="11429254" y="4522524"/>
+            <a:ext cx="285113" cy="369332"/>
+          </a:xfrm>
+          <a:prstGeom prst="rect">
+            <a:avLst/>
+          </a:prstGeom>
+          <a:noFill/>
+        </p:spPr>
+        <p:txBody>
+          <a:bodyPr wrap="square">
+            <a:spAutoFit/>
+          </a:bodyPr>
+          <a:lstStyle/>
+          <a:p>
+            <a:r>
+              <a:rPr lang="zh-CN" altLang="en-US" dirty="0">
+                <a:solidFill>
+                  <a:schemeClr val="accent1"/>
+                </a:solidFill>
+              </a:rPr>
+              <a:t>よ</a:t>
+            </a:r>
+          </a:p>
+        </p:txBody>
+      </p:sp>
+      <p:sp>
+        <p:nvSpPr>
+          <p:cNvPr id="34" name="文本框 33">
+            <a:extLst>
+              <a:ext uri="{FF2B5EF4-FFF2-40B4-BE49-F238E27FC236}">
+                <a16:creationId xmlns:a16="http://schemas.microsoft.com/office/drawing/2014/main" id="{9BD60FEA-29EE-4CA2-A2CD-6CD664ACA791}"/>
+              </a:ext>
+            </a:extLst>
+          </p:cNvPr>
+          <p:cNvSpPr txBox="1"/>
+          <p:nvPr/>
+        </p:nvSpPr>
+        <p:spPr>
+          <a:xfrm>
+            <a:off x="2162641" y="5130078"/>
+            <a:ext cx="1549206" cy="369332"/>
+          </a:xfrm>
+          <a:prstGeom prst="rect">
+            <a:avLst/>
+          </a:prstGeom>
+          <a:noFill/>
+        </p:spPr>
+        <p:txBody>
+          <a:bodyPr wrap="square">
+            <a:spAutoFit/>
+          </a:bodyPr>
+          <a:lstStyle/>
+          <a:p>
+            <a:r>
+              <a:rPr lang="zh-CN" altLang="en-US" dirty="0">
+                <a:solidFill>
+                  <a:schemeClr val="accent1"/>
+                </a:solidFill>
+              </a:rPr>
+              <a:t>まんなか</a:t>
+            </a:r>
+          </a:p>
+        </p:txBody>
+      </p:sp>
+      <p:sp>
+        <p:nvSpPr>
+          <p:cNvPr id="36" name="文本框 35">
+            <a:extLst>
+              <a:ext uri="{FF2B5EF4-FFF2-40B4-BE49-F238E27FC236}">
+                <a16:creationId xmlns:a16="http://schemas.microsoft.com/office/drawing/2014/main" id="{BC1830CF-0774-4112-9186-4ECD872C0568}"/>
+              </a:ext>
+            </a:extLst>
+          </p:cNvPr>
+          <p:cNvSpPr txBox="1"/>
+          <p:nvPr/>
+        </p:nvSpPr>
+        <p:spPr>
+          <a:xfrm>
+            <a:off x="5548764" y="5152234"/>
+            <a:ext cx="879844" cy="369332"/>
+          </a:xfrm>
+          <a:prstGeom prst="rect">
+            <a:avLst/>
+          </a:prstGeom>
+          <a:noFill/>
+        </p:spPr>
+        <p:txBody>
+          <a:bodyPr wrap="square">
+            <a:spAutoFit/>
+          </a:bodyPr>
+          <a:lstStyle/>
+          <a:p>
+            <a:r>
+              <a:rPr lang="zh-CN" altLang="en-US" dirty="0">
+                <a:solidFill>
+                  <a:schemeClr val="accent1"/>
+                </a:solidFill>
+              </a:rPr>
+              <a:t>にちじ</a:t>
+            </a:r>
+          </a:p>
+        </p:txBody>
+      </p:sp>
+      <p:sp>
+        <p:nvSpPr>
+          <p:cNvPr id="38" name="文本框 37">
+            <a:extLst>
+              <a:ext uri="{FF2B5EF4-FFF2-40B4-BE49-F238E27FC236}">
+                <a16:creationId xmlns:a16="http://schemas.microsoft.com/office/drawing/2014/main" id="{A7F8FADA-A9DB-429B-B385-16B8B0954F09}"/>
+              </a:ext>
+            </a:extLst>
+          </p:cNvPr>
+          <p:cNvSpPr txBox="1"/>
+          <p:nvPr/>
+        </p:nvSpPr>
+        <p:spPr>
+          <a:xfrm>
+            <a:off x="8004544" y="5141601"/>
+            <a:ext cx="832175" cy="369332"/>
+          </a:xfrm>
+          <a:prstGeom prst="rect">
+            <a:avLst/>
+          </a:prstGeom>
+          <a:noFill/>
+        </p:spPr>
+        <p:txBody>
+          <a:bodyPr wrap="square">
+            <a:spAutoFit/>
+          </a:bodyPr>
+          <a:lstStyle/>
+          <a:p>
+            <a:r>
+              <a:rPr lang="zh-CN" altLang="en-US">
+                <a:solidFill>
+                  <a:schemeClr val="accent1"/>
+                </a:solidFill>
+              </a:rPr>
+              <a:t>さ</a:t>
+            </a:r>
+            <a:endParaRPr lang="zh-CN" altLang="en-US" dirty="0">
+              <a:solidFill>
+                <a:schemeClr val="accent1"/>
+              </a:solidFill>
+            </a:endParaRPr>
+          </a:p>
+        </p:txBody>
+      </p:sp>
+      <p:sp>
+        <p:nvSpPr>
+          <p:cNvPr id="40" name="文本框 39">
+            <a:extLst>
+              <a:ext uri="{FF2B5EF4-FFF2-40B4-BE49-F238E27FC236}">
+                <a16:creationId xmlns:a16="http://schemas.microsoft.com/office/drawing/2014/main" id="{8E4918A1-BAFB-4BA6-95A2-60CB453A36C8}"/>
+              </a:ext>
+            </a:extLst>
+          </p:cNvPr>
+          <p:cNvSpPr txBox="1"/>
+          <p:nvPr/>
+        </p:nvSpPr>
+        <p:spPr>
+          <a:xfrm>
+            <a:off x="9427630" y="5130078"/>
+            <a:ext cx="1230719" cy="369332"/>
+          </a:xfrm>
+          <a:prstGeom prst="rect">
+            <a:avLst/>
+          </a:prstGeom>
+          <a:noFill/>
+        </p:spPr>
+        <p:txBody>
+          <a:bodyPr wrap="square">
+            <a:spAutoFit/>
+          </a:bodyPr>
+          <a:lstStyle/>
+          <a:p>
+            <a:r>
+              <a:rPr lang="zh-CN" altLang="en-US" dirty="0">
+                <a:solidFill>
+                  <a:schemeClr val="accent1"/>
+                </a:solidFill>
+              </a:rPr>
+              <a:t>ていあん</a:t>
+            </a:r>
+          </a:p>
+        </p:txBody>
+      </p:sp>
+      <p:sp>
+        <p:nvSpPr>
+          <p:cNvPr id="42" name="文本框 41">
+            <a:extLst>
+              <a:ext uri="{FF2B5EF4-FFF2-40B4-BE49-F238E27FC236}">
+                <a16:creationId xmlns:a16="http://schemas.microsoft.com/office/drawing/2014/main" id="{6FA5994A-CD86-4F1A-92A9-8313BD72C11E}"/>
+              </a:ext>
+            </a:extLst>
+          </p:cNvPr>
+          <p:cNvSpPr txBox="1"/>
+          <p:nvPr/>
+        </p:nvSpPr>
+        <p:spPr>
+          <a:xfrm>
+            <a:off x="-76201" y="5791460"/>
+            <a:ext cx="979969" cy="369332"/>
+          </a:xfrm>
+          <a:prstGeom prst="rect">
+            <a:avLst/>
+          </a:prstGeom>
+          <a:noFill/>
+        </p:spPr>
+        <p:txBody>
+          <a:bodyPr wrap="square">
+            <a:spAutoFit/>
+          </a:bodyPr>
+          <a:lstStyle/>
+          <a:p>
+            <a:r>
+              <a:rPr lang="zh-CN" altLang="en-US" dirty="0">
+                <a:solidFill>
+                  <a:schemeClr val="accent1"/>
+                </a:solidFill>
+              </a:rPr>
+              <a:t>うご</a:t>
+            </a:r>
+          </a:p>
+        </p:txBody>
+      </p:sp>
+    </p:spTree>
+    <p:extLst>
+      <p:ext uri="{BB962C8B-B14F-4D97-AF65-F5344CB8AC3E}">
+        <p14:creationId xmlns:p14="http://schemas.microsoft.com/office/powerpoint/2010/main" val="145446975"/>
+      </p:ext>
+    </p:extLst>
   </p:cSld>
   <p:clrMapOvr>
     <a:masterClrMapping/>

</xml_diff>

<commit_message>
update listening 22_12 1-3
</commit_message>
<xml_diff>
--- a/LISTEN/2_22_12.pptx
+++ b/LISTEN/2_22_12.pptx
@@ -244,7 +244,7 @@
           <a:p>
             <a:fld id="{D997B5FA-0921-464F-AAE1-844C04324D75}" type="datetimeFigureOut">
               <a:rPr lang="zh-CN" altLang="en-US" smtClean="0"/>
-              <a:t>2025/9/28/Sunday</a:t>
+              <a:t>2025/9/29/Monday</a:t>
             </a:fld>
             <a:endParaRPr lang="zh-CN" altLang="en-US"/>
           </a:p>
@@ -407,7 +407,7 @@
           <a:p>
             <a:fld id="{D997B5FA-0921-464F-AAE1-844C04324D75}" type="datetimeFigureOut">
               <a:rPr lang="zh-CN" altLang="en-US" smtClean="0"/>
-              <a:t>2025/9/28/Sunday</a:t>
+              <a:t>2025/9/29/Monday</a:t>
             </a:fld>
             <a:endParaRPr lang="zh-CN" altLang="en-US"/>
           </a:p>
@@ -580,7 +580,7 @@
           <a:p>
             <a:fld id="{D997B5FA-0921-464F-AAE1-844C04324D75}" type="datetimeFigureOut">
               <a:rPr lang="zh-CN" altLang="en-US" smtClean="0"/>
-              <a:t>2025/9/28/Sunday</a:t>
+              <a:t>2025/9/29/Monday</a:t>
             </a:fld>
             <a:endParaRPr lang="zh-CN" altLang="en-US"/>
           </a:p>
@@ -743,7 +743,7 @@
           <a:p>
             <a:fld id="{D997B5FA-0921-464F-AAE1-844C04324D75}" type="datetimeFigureOut">
               <a:rPr lang="zh-CN" altLang="en-US" smtClean="0"/>
-              <a:t>2025/9/28/Sunday</a:t>
+              <a:t>2025/9/29/Monday</a:t>
             </a:fld>
             <a:endParaRPr lang="zh-CN" altLang="en-US"/>
           </a:p>
@@ -983,7 +983,7 @@
           <a:p>
             <a:fld id="{D997B5FA-0921-464F-AAE1-844C04324D75}" type="datetimeFigureOut">
               <a:rPr lang="zh-CN" altLang="en-US" smtClean="0"/>
-              <a:t>2025/9/28/Sunday</a:t>
+              <a:t>2025/9/29/Monday</a:t>
             </a:fld>
             <a:endParaRPr lang="zh-CN" altLang="en-US"/>
           </a:p>
@@ -1207,7 +1207,7 @@
           <a:p>
             <a:fld id="{D997B5FA-0921-464F-AAE1-844C04324D75}" type="datetimeFigureOut">
               <a:rPr lang="zh-CN" altLang="en-US" smtClean="0"/>
-              <a:t>2025/9/28/Sunday</a:t>
+              <a:t>2025/9/29/Monday</a:t>
             </a:fld>
             <a:endParaRPr lang="zh-CN" altLang="en-US"/>
           </a:p>
@@ -1566,7 +1566,7 @@
           <a:p>
             <a:fld id="{D997B5FA-0921-464F-AAE1-844C04324D75}" type="datetimeFigureOut">
               <a:rPr lang="zh-CN" altLang="en-US" smtClean="0"/>
-              <a:t>2025/9/28/Sunday</a:t>
+              <a:t>2025/9/29/Monday</a:t>
             </a:fld>
             <a:endParaRPr lang="zh-CN" altLang="en-US"/>
           </a:p>
@@ -1678,7 +1678,7 @@
           <a:p>
             <a:fld id="{D997B5FA-0921-464F-AAE1-844C04324D75}" type="datetimeFigureOut">
               <a:rPr lang="zh-CN" altLang="en-US" smtClean="0"/>
-              <a:t>2025/9/28/Sunday</a:t>
+              <a:t>2025/9/29/Monday</a:t>
             </a:fld>
             <a:endParaRPr lang="zh-CN" altLang="en-US"/>
           </a:p>
@@ -1768,7 +1768,7 @@
           <a:p>
             <a:fld id="{D997B5FA-0921-464F-AAE1-844C04324D75}" type="datetimeFigureOut">
               <a:rPr lang="zh-CN" altLang="en-US" smtClean="0"/>
-              <a:t>2025/9/28/Sunday</a:t>
+              <a:t>2025/9/29/Monday</a:t>
             </a:fld>
             <a:endParaRPr lang="zh-CN" altLang="en-US"/>
           </a:p>
@@ -2038,7 +2038,7 @@
           <a:p>
             <a:fld id="{D997B5FA-0921-464F-AAE1-844C04324D75}" type="datetimeFigureOut">
               <a:rPr lang="zh-CN" altLang="en-US" smtClean="0"/>
-              <a:t>2025/9/28/Sunday</a:t>
+              <a:t>2025/9/29/Monday</a:t>
             </a:fld>
             <a:endParaRPr lang="zh-CN" altLang="en-US"/>
           </a:p>
@@ -2285,7 +2285,7 @@
           <a:p>
             <a:fld id="{D997B5FA-0921-464F-AAE1-844C04324D75}" type="datetimeFigureOut">
               <a:rPr lang="zh-CN" altLang="en-US" smtClean="0"/>
-              <a:t>2025/9/28/Sunday</a:t>
+              <a:t>2025/9/29/Monday</a:t>
             </a:fld>
             <a:endParaRPr lang="zh-CN" altLang="en-US"/>
           </a:p>
@@ -2491,7 +2491,7 @@
           <a:p>
             <a:fld id="{D997B5FA-0921-464F-AAE1-844C04324D75}" type="datetimeFigureOut">
               <a:rPr lang="zh-CN" altLang="en-US" smtClean="0"/>
-              <a:t>2025/9/28/Sunday</a:t>
+              <a:t>2025/9/29/Monday</a:t>
             </a:fld>
             <a:endParaRPr lang="zh-CN" altLang="en-US"/>
           </a:p>
@@ -5062,6 +5062,669 @@
           </a:prstGeom>
         </p:spPr>
       </p:pic>
+      <p:sp>
+        <p:nvSpPr>
+          <p:cNvPr id="5" name="文本框 4">
+            <a:extLst>
+              <a:ext uri="{FF2B5EF4-FFF2-40B4-BE49-F238E27FC236}">
+                <a16:creationId xmlns:a16="http://schemas.microsoft.com/office/drawing/2014/main" id="{71839857-82D0-4E6A-B4C3-7C4C43B13872}"/>
+              </a:ext>
+            </a:extLst>
+          </p:cNvPr>
+          <p:cNvSpPr txBox="1"/>
+          <p:nvPr/>
+        </p:nvSpPr>
+        <p:spPr>
+          <a:xfrm>
+            <a:off x="2049425" y="1936530"/>
+            <a:ext cx="1087180" cy="307777"/>
+          </a:xfrm>
+          <a:prstGeom prst="rect">
+            <a:avLst/>
+          </a:prstGeom>
+          <a:noFill/>
+        </p:spPr>
+        <p:txBody>
+          <a:bodyPr wrap="square">
+            <a:spAutoFit/>
+          </a:bodyPr>
+          <a:lstStyle/>
+          <a:p>
+            <a:r>
+              <a:rPr lang="zh-CN" altLang="en-US" sz="1400" dirty="0">
+                <a:solidFill>
+                  <a:schemeClr val="accent1"/>
+                </a:solidFill>
+              </a:rPr>
+              <a:t>きかくしょ</a:t>
+            </a:r>
+          </a:p>
+        </p:txBody>
+      </p:sp>
+      <p:sp>
+        <p:nvSpPr>
+          <p:cNvPr id="6" name="文本框 5">
+            <a:extLst>
+              <a:ext uri="{FF2B5EF4-FFF2-40B4-BE49-F238E27FC236}">
+                <a16:creationId xmlns:a16="http://schemas.microsoft.com/office/drawing/2014/main" id="{A1D75CFE-5884-4096-80F0-F81099859043}"/>
+              </a:ext>
+            </a:extLst>
+          </p:cNvPr>
+          <p:cNvSpPr txBox="1"/>
+          <p:nvPr/>
+        </p:nvSpPr>
+        <p:spPr>
+          <a:xfrm>
+            <a:off x="4426167" y="1937367"/>
+            <a:ext cx="693774" cy="307777"/>
+          </a:xfrm>
+          <a:prstGeom prst="rect">
+            <a:avLst/>
+          </a:prstGeom>
+          <a:noFill/>
+        </p:spPr>
+        <p:txBody>
+          <a:bodyPr wrap="square">
+            <a:spAutoFit/>
+          </a:bodyPr>
+          <a:lstStyle/>
+          <a:p>
+            <a:r>
+              <a:rPr lang="zh-CN" altLang="en-US" sz="1400" dirty="0">
+                <a:solidFill>
+                  <a:schemeClr val="accent1"/>
+                </a:solidFill>
+              </a:rPr>
+              <a:t>おさ</a:t>
+            </a:r>
+          </a:p>
+        </p:txBody>
+      </p:sp>
+      <p:sp>
+        <p:nvSpPr>
+          <p:cNvPr id="8" name="文本框 7">
+            <a:extLst>
+              <a:ext uri="{FF2B5EF4-FFF2-40B4-BE49-F238E27FC236}">
+                <a16:creationId xmlns:a16="http://schemas.microsoft.com/office/drawing/2014/main" id="{D985FEA9-188F-468E-B82C-0CEDA4F25E6D}"/>
+              </a:ext>
+            </a:extLst>
+          </p:cNvPr>
+          <p:cNvSpPr txBox="1"/>
+          <p:nvPr/>
+        </p:nvSpPr>
+        <p:spPr>
+          <a:xfrm>
+            <a:off x="4994644" y="1951918"/>
+            <a:ext cx="661878" cy="276999"/>
+          </a:xfrm>
+          <a:prstGeom prst="rect">
+            <a:avLst/>
+          </a:prstGeom>
+          <a:noFill/>
+        </p:spPr>
+        <p:txBody>
+          <a:bodyPr wrap="square">
+            <a:spAutoFit/>
+          </a:bodyPr>
+          <a:lstStyle/>
+          <a:p>
+            <a:r>
+              <a:rPr lang="zh-CN" altLang="en-US" sz="1200" dirty="0">
+                <a:solidFill>
+                  <a:schemeClr val="accent1"/>
+                </a:solidFill>
+              </a:rPr>
+              <a:t>おとな</a:t>
+            </a:r>
+          </a:p>
+        </p:txBody>
+      </p:sp>
+      <p:sp>
+        <p:nvSpPr>
+          <p:cNvPr id="10" name="文本框 9">
+            <a:extLst>
+              <a:ext uri="{FF2B5EF4-FFF2-40B4-BE49-F238E27FC236}">
+                <a16:creationId xmlns:a16="http://schemas.microsoft.com/office/drawing/2014/main" id="{0EEE626A-7995-4521-A009-A77C6FBCA92A}"/>
+              </a:ext>
+            </a:extLst>
+          </p:cNvPr>
+          <p:cNvSpPr txBox="1"/>
+          <p:nvPr/>
+        </p:nvSpPr>
+        <p:spPr>
+          <a:xfrm>
+            <a:off x="241891" y="3244333"/>
+            <a:ext cx="736305" cy="369332"/>
+          </a:xfrm>
+          <a:prstGeom prst="rect">
+            <a:avLst/>
+          </a:prstGeom>
+          <a:noFill/>
+        </p:spPr>
+        <p:txBody>
+          <a:bodyPr wrap="square">
+            <a:spAutoFit/>
+          </a:bodyPr>
+          <a:lstStyle/>
+          <a:p>
+            <a:r>
+              <a:rPr lang="zh-CN" altLang="en-US" dirty="0">
+                <a:solidFill>
+                  <a:schemeClr val="accent1"/>
+                </a:solidFill>
+              </a:rPr>
+              <a:t>はこ</a:t>
+            </a:r>
+          </a:p>
+        </p:txBody>
+      </p:sp>
+      <p:sp>
+        <p:nvSpPr>
+          <p:cNvPr id="12" name="文本框 11">
+            <a:extLst>
+              <a:ext uri="{FF2B5EF4-FFF2-40B4-BE49-F238E27FC236}">
+                <a16:creationId xmlns:a16="http://schemas.microsoft.com/office/drawing/2014/main" id="{D116743C-D810-442A-9EC8-9EF3D892170A}"/>
+              </a:ext>
+            </a:extLst>
+          </p:cNvPr>
+          <p:cNvSpPr txBox="1"/>
+          <p:nvPr/>
+        </p:nvSpPr>
+        <p:spPr>
+          <a:xfrm>
+            <a:off x="1432737" y="3317356"/>
+            <a:ext cx="1225403" cy="261610"/>
+          </a:xfrm>
+          <a:prstGeom prst="rect">
+            <a:avLst/>
+          </a:prstGeom>
+          <a:noFill/>
+        </p:spPr>
+        <p:txBody>
+          <a:bodyPr wrap="square">
+            <a:spAutoFit/>
+          </a:bodyPr>
+          <a:lstStyle/>
+          <a:p>
+            <a:r>
+              <a:rPr lang="zh-CN" altLang="en-US" sz="1100" dirty="0">
+                <a:solidFill>
+                  <a:schemeClr val="accent1"/>
+                </a:solidFill>
+              </a:rPr>
+              <a:t>こうきゅうかん</a:t>
+            </a:r>
+          </a:p>
+        </p:txBody>
+      </p:sp>
+      <p:sp>
+        <p:nvSpPr>
+          <p:cNvPr id="14" name="文本框 13">
+            <a:extLst>
+              <a:ext uri="{FF2B5EF4-FFF2-40B4-BE49-F238E27FC236}">
+                <a16:creationId xmlns:a16="http://schemas.microsoft.com/office/drawing/2014/main" id="{F97B0EEA-0054-4E98-9968-877FCE860E8F}"/>
+              </a:ext>
+            </a:extLst>
+          </p:cNvPr>
+          <p:cNvSpPr txBox="1"/>
+          <p:nvPr/>
+        </p:nvSpPr>
+        <p:spPr>
+          <a:xfrm>
+            <a:off x="2400300" y="3263495"/>
+            <a:ext cx="736305" cy="369332"/>
+          </a:xfrm>
+          <a:prstGeom prst="rect">
+            <a:avLst/>
+          </a:prstGeom>
+          <a:noFill/>
+        </p:spPr>
+        <p:txBody>
+          <a:bodyPr wrap="square">
+            <a:spAutoFit/>
+          </a:bodyPr>
+          <a:lstStyle/>
+          <a:p>
+            <a:r>
+              <a:rPr lang="zh-CN" altLang="en-US" dirty="0">
+                <a:solidFill>
+                  <a:schemeClr val="accent1"/>
+                </a:solidFill>
+              </a:rPr>
+              <a:t>だ</a:t>
+            </a:r>
+          </a:p>
+        </p:txBody>
+      </p:sp>
+      <p:sp>
+        <p:nvSpPr>
+          <p:cNvPr id="16" name="文本框 15">
+            <a:extLst>
+              <a:ext uri="{FF2B5EF4-FFF2-40B4-BE49-F238E27FC236}">
+                <a16:creationId xmlns:a16="http://schemas.microsoft.com/office/drawing/2014/main" id="{CAADD690-2B5D-479C-9151-28617A200A57}"/>
+              </a:ext>
+            </a:extLst>
+          </p:cNvPr>
+          <p:cNvSpPr txBox="1"/>
+          <p:nvPr/>
+        </p:nvSpPr>
+        <p:spPr>
+          <a:xfrm>
+            <a:off x="3344306" y="3263495"/>
+            <a:ext cx="1031358" cy="369332"/>
+          </a:xfrm>
+          <a:prstGeom prst="rect">
+            <a:avLst/>
+          </a:prstGeom>
+          <a:noFill/>
+        </p:spPr>
+        <p:txBody>
+          <a:bodyPr wrap="square">
+            <a:spAutoFit/>
+          </a:bodyPr>
+          <a:lstStyle/>
+          <a:p>
+            <a:r>
+              <a:rPr lang="zh-CN" altLang="en-US" dirty="0">
+                <a:solidFill>
+                  <a:schemeClr val="accent1"/>
+                </a:solidFill>
+              </a:rPr>
+              <a:t>ねら</a:t>
+            </a:r>
+          </a:p>
+        </p:txBody>
+      </p:sp>
+      <p:sp>
+        <p:nvSpPr>
+          <p:cNvPr id="18" name="文本框 17">
+            <a:extLst>
+              <a:ext uri="{FF2B5EF4-FFF2-40B4-BE49-F238E27FC236}">
+                <a16:creationId xmlns:a16="http://schemas.microsoft.com/office/drawing/2014/main" id="{42AD0B75-1175-4C55-AAC7-40A822821BC0}"/>
+              </a:ext>
+            </a:extLst>
+          </p:cNvPr>
+          <p:cNvSpPr txBox="1"/>
+          <p:nvPr/>
+        </p:nvSpPr>
+        <p:spPr>
+          <a:xfrm>
+            <a:off x="610043" y="3667526"/>
+            <a:ext cx="1225403" cy="369332"/>
+          </a:xfrm>
+          <a:prstGeom prst="rect">
+            <a:avLst/>
+          </a:prstGeom>
+          <a:noFill/>
+        </p:spPr>
+        <p:txBody>
+          <a:bodyPr wrap="square">
+            <a:spAutoFit/>
+          </a:bodyPr>
+          <a:lstStyle/>
+          <a:p>
+            <a:r>
+              <a:rPr lang="zh-CN" altLang="en-US" dirty="0">
+                <a:solidFill>
+                  <a:schemeClr val="accent1"/>
+                </a:solidFill>
+              </a:rPr>
+              <a:t>はんばい</a:t>
+            </a:r>
+          </a:p>
+        </p:txBody>
+      </p:sp>
+      <p:sp>
+        <p:nvSpPr>
+          <p:cNvPr id="20" name="文本框 19">
+            <a:extLst>
+              <a:ext uri="{FF2B5EF4-FFF2-40B4-BE49-F238E27FC236}">
+                <a16:creationId xmlns:a16="http://schemas.microsoft.com/office/drawing/2014/main" id="{A8C6A504-5631-4F6E-B5DE-E107E4B8762D}"/>
+              </a:ext>
+            </a:extLst>
+          </p:cNvPr>
+          <p:cNvSpPr txBox="1"/>
+          <p:nvPr/>
+        </p:nvSpPr>
+        <p:spPr>
+          <a:xfrm>
+            <a:off x="2411299" y="3693114"/>
+            <a:ext cx="1544013" cy="369332"/>
+          </a:xfrm>
+          <a:prstGeom prst="rect">
+            <a:avLst/>
+          </a:prstGeom>
+          <a:noFill/>
+        </p:spPr>
+        <p:txBody>
+          <a:bodyPr wrap="square">
+            <a:spAutoFit/>
+          </a:bodyPr>
+          <a:lstStyle/>
+          <a:p>
+            <a:r>
+              <a:rPr lang="zh-CN" altLang="en-US" dirty="0">
+                <a:solidFill>
+                  <a:schemeClr val="accent1"/>
+                </a:solidFill>
+              </a:rPr>
+              <a:t>せってい</a:t>
+            </a:r>
+          </a:p>
+        </p:txBody>
+      </p:sp>
+      <p:sp>
+        <p:nvSpPr>
+          <p:cNvPr id="22" name="文本框 21">
+            <a:extLst>
+              <a:ext uri="{FF2B5EF4-FFF2-40B4-BE49-F238E27FC236}">
+                <a16:creationId xmlns:a16="http://schemas.microsoft.com/office/drawing/2014/main" id="{FE2F2C36-5CF8-43CC-8BD6-D5AAD1E53F09}"/>
+              </a:ext>
+            </a:extLst>
+          </p:cNvPr>
+          <p:cNvSpPr txBox="1"/>
+          <p:nvPr/>
+        </p:nvSpPr>
+        <p:spPr>
+          <a:xfrm>
+            <a:off x="2071055" y="4170597"/>
+            <a:ext cx="1544013" cy="369332"/>
+          </a:xfrm>
+          <a:prstGeom prst="rect">
+            <a:avLst/>
+          </a:prstGeom>
+          <a:noFill/>
+        </p:spPr>
+        <p:txBody>
+          <a:bodyPr wrap="square">
+            <a:spAutoFit/>
+          </a:bodyPr>
+          <a:lstStyle/>
+          <a:p>
+            <a:r>
+              <a:rPr lang="zh-CN" altLang="en-US" dirty="0">
+                <a:solidFill>
+                  <a:schemeClr val="accent1"/>
+                </a:solidFill>
+              </a:rPr>
+              <a:t>みせのたな</a:t>
+            </a:r>
+          </a:p>
+        </p:txBody>
+      </p:sp>
+      <p:sp>
+        <p:nvSpPr>
+          <p:cNvPr id="24" name="文本框 23">
+            <a:extLst>
+              <a:ext uri="{FF2B5EF4-FFF2-40B4-BE49-F238E27FC236}">
+                <a16:creationId xmlns:a16="http://schemas.microsoft.com/office/drawing/2014/main" id="{045ED79D-DBDC-4B5D-8CA6-4D6C953D9F6F}"/>
+              </a:ext>
+            </a:extLst>
+          </p:cNvPr>
+          <p:cNvSpPr txBox="1"/>
+          <p:nvPr/>
+        </p:nvSpPr>
+        <p:spPr>
+          <a:xfrm>
+            <a:off x="3700128" y="4201374"/>
+            <a:ext cx="1807537" cy="307777"/>
+          </a:xfrm>
+          <a:prstGeom prst="rect">
+            <a:avLst/>
+          </a:prstGeom>
+          <a:noFill/>
+        </p:spPr>
+        <p:txBody>
+          <a:bodyPr wrap="square">
+            <a:spAutoFit/>
+          </a:bodyPr>
+          <a:lstStyle/>
+          <a:p>
+            <a:r>
+              <a:rPr lang="zh-CN" altLang="en-US" sz="1400" dirty="0">
+                <a:solidFill>
+                  <a:schemeClr val="accent1"/>
+                </a:solidFill>
+              </a:rPr>
+              <a:t>しょうひしゃ</a:t>
+            </a:r>
+          </a:p>
+        </p:txBody>
+      </p:sp>
+      <p:sp>
+        <p:nvSpPr>
+          <p:cNvPr id="26" name="文本框 25">
+            <a:extLst>
+              <a:ext uri="{FF2B5EF4-FFF2-40B4-BE49-F238E27FC236}">
+                <a16:creationId xmlns:a16="http://schemas.microsoft.com/office/drawing/2014/main" id="{4C7000B5-5DC7-445E-9C9E-07B45CE01412}"/>
+              </a:ext>
+            </a:extLst>
+          </p:cNvPr>
+          <p:cNvSpPr txBox="1"/>
+          <p:nvPr/>
+        </p:nvSpPr>
+        <p:spPr>
+          <a:xfrm>
+            <a:off x="4994644" y="4169746"/>
+            <a:ext cx="513021" cy="369332"/>
+          </a:xfrm>
+          <a:prstGeom prst="rect">
+            <a:avLst/>
+          </a:prstGeom>
+          <a:noFill/>
+        </p:spPr>
+        <p:txBody>
+          <a:bodyPr wrap="square">
+            <a:spAutoFit/>
+          </a:bodyPr>
+          <a:lstStyle/>
+          <a:p>
+            <a:r>
+              <a:rPr lang="zh-CN" altLang="en-US" dirty="0">
+                <a:solidFill>
+                  <a:schemeClr val="accent1"/>
+                </a:solidFill>
+              </a:rPr>
+              <a:t>と</a:t>
+            </a:r>
+          </a:p>
+        </p:txBody>
+      </p:sp>
+      <p:sp>
+        <p:nvSpPr>
+          <p:cNvPr id="28" name="文本框 27">
+            <a:extLst>
+              <a:ext uri="{FF2B5EF4-FFF2-40B4-BE49-F238E27FC236}">
+                <a16:creationId xmlns:a16="http://schemas.microsoft.com/office/drawing/2014/main" id="{8D61D803-1D39-44AA-8F47-60203B417965}"/>
+              </a:ext>
+            </a:extLst>
+          </p:cNvPr>
+          <p:cNvSpPr txBox="1"/>
+          <p:nvPr/>
+        </p:nvSpPr>
+        <p:spPr>
+          <a:xfrm>
+            <a:off x="8059843" y="4139819"/>
+            <a:ext cx="1031358" cy="369332"/>
+          </a:xfrm>
+          <a:prstGeom prst="rect">
+            <a:avLst/>
+          </a:prstGeom>
+          <a:noFill/>
+        </p:spPr>
+        <p:txBody>
+          <a:bodyPr wrap="square">
+            <a:spAutoFit/>
+          </a:bodyPr>
+          <a:lstStyle/>
+          <a:p>
+            <a:r>
+              <a:rPr lang="zh-CN" altLang="en-US" dirty="0">
+                <a:solidFill>
+                  <a:schemeClr val="accent1"/>
+                </a:solidFill>
+              </a:rPr>
+              <a:t>めだつ</a:t>
+            </a:r>
+          </a:p>
+        </p:txBody>
+      </p:sp>
+      <p:sp>
+        <p:nvSpPr>
+          <p:cNvPr id="30" name="文本框 29">
+            <a:extLst>
+              <a:ext uri="{FF2B5EF4-FFF2-40B4-BE49-F238E27FC236}">
+                <a16:creationId xmlns:a16="http://schemas.microsoft.com/office/drawing/2014/main" id="{D562E5E4-FD9A-42C0-B80D-EE86CF95E948}"/>
+              </a:ext>
+            </a:extLst>
+          </p:cNvPr>
+          <p:cNvSpPr txBox="1"/>
+          <p:nvPr/>
+        </p:nvSpPr>
+        <p:spPr>
+          <a:xfrm>
+            <a:off x="1800293" y="5126251"/>
+            <a:ext cx="1544013" cy="276999"/>
+          </a:xfrm>
+          <a:prstGeom prst="rect">
+            <a:avLst/>
+          </a:prstGeom>
+          <a:noFill/>
+        </p:spPr>
+        <p:txBody>
+          <a:bodyPr wrap="square">
+            <a:spAutoFit/>
+          </a:bodyPr>
+          <a:lstStyle/>
+          <a:p>
+            <a:r>
+              <a:rPr lang="zh-CN" altLang="en-US" sz="1200" dirty="0">
+                <a:solidFill>
+                  <a:schemeClr val="accent1"/>
+                </a:solidFill>
+              </a:rPr>
+              <a:t>ちょうせい</a:t>
+            </a:r>
+          </a:p>
+        </p:txBody>
+      </p:sp>
+      <p:sp>
+        <p:nvSpPr>
+          <p:cNvPr id="32" name="文本框 31">
+            <a:extLst>
+              <a:ext uri="{FF2B5EF4-FFF2-40B4-BE49-F238E27FC236}">
+                <a16:creationId xmlns:a16="http://schemas.microsoft.com/office/drawing/2014/main" id="{DB9C1239-4AA7-4B01-8A25-0020DB0F05EB}"/>
+              </a:ext>
+            </a:extLst>
+          </p:cNvPr>
+          <p:cNvSpPr txBox="1"/>
+          <p:nvPr/>
+        </p:nvSpPr>
+        <p:spPr>
+          <a:xfrm>
+            <a:off x="5325583" y="5033918"/>
+            <a:ext cx="990157" cy="369332"/>
+          </a:xfrm>
+          <a:prstGeom prst="rect">
+            <a:avLst/>
+          </a:prstGeom>
+          <a:noFill/>
+        </p:spPr>
+        <p:txBody>
+          <a:bodyPr wrap="square">
+            <a:spAutoFit/>
+          </a:bodyPr>
+          <a:lstStyle/>
+          <a:p>
+            <a:r>
+              <a:rPr lang="zh-CN" altLang="en-US" dirty="0">
+                <a:solidFill>
+                  <a:schemeClr val="accent1"/>
+                </a:solidFill>
+              </a:rPr>
+              <a:t>してき</a:t>
+            </a:r>
+          </a:p>
+        </p:txBody>
+      </p:sp>
+      <p:sp>
+        <p:nvSpPr>
+          <p:cNvPr id="34" name="文本框 33">
+            <a:extLst>
+              <a:ext uri="{FF2B5EF4-FFF2-40B4-BE49-F238E27FC236}">
+                <a16:creationId xmlns:a16="http://schemas.microsoft.com/office/drawing/2014/main" id="{58D2C464-42D0-40DC-B884-DF4E4D765EF2}"/>
+              </a:ext>
+            </a:extLst>
+          </p:cNvPr>
+          <p:cNvSpPr txBox="1"/>
+          <p:nvPr/>
+        </p:nvSpPr>
+        <p:spPr>
+          <a:xfrm>
+            <a:off x="6315740" y="5126251"/>
+            <a:ext cx="1403131" cy="276999"/>
+          </a:xfrm>
+          <a:prstGeom prst="rect">
+            <a:avLst/>
+          </a:prstGeom>
+          <a:noFill/>
+        </p:spPr>
+        <p:txBody>
+          <a:bodyPr wrap="square">
+            <a:spAutoFit/>
+          </a:bodyPr>
+          <a:lstStyle/>
+          <a:p>
+            <a:r>
+              <a:rPr lang="zh-CN" altLang="en-US" sz="1200" dirty="0">
+                <a:solidFill>
+                  <a:schemeClr val="accent1"/>
+                </a:solidFill>
+              </a:rPr>
+              <a:t>しゅうせい</a:t>
+            </a:r>
+          </a:p>
+        </p:txBody>
+      </p:sp>
+      <p:sp>
+        <p:nvSpPr>
+          <p:cNvPr id="36" name="文本框 35">
+            <a:extLst>
+              <a:ext uri="{FF2B5EF4-FFF2-40B4-BE49-F238E27FC236}">
+                <a16:creationId xmlns:a16="http://schemas.microsoft.com/office/drawing/2014/main" id="{EF236009-55EA-4B68-ABF7-1D55259FDE46}"/>
+              </a:ext>
+            </a:extLst>
+          </p:cNvPr>
+          <p:cNvSpPr txBox="1"/>
+          <p:nvPr/>
+        </p:nvSpPr>
+        <p:spPr>
+          <a:xfrm>
+            <a:off x="1326778" y="5500060"/>
+            <a:ext cx="1544013" cy="369332"/>
+          </a:xfrm>
+          <a:prstGeom prst="rect">
+            <a:avLst/>
+          </a:prstGeom>
+          <a:noFill/>
+        </p:spPr>
+        <p:txBody>
+          <a:bodyPr wrap="square">
+            <a:spAutoFit/>
+          </a:bodyPr>
+          <a:lstStyle/>
+          <a:p>
+            <a:r>
+              <a:rPr lang="zh-CN" altLang="en-US" dirty="0">
+                <a:solidFill>
+                  <a:schemeClr val="accent1"/>
+                </a:solidFill>
+              </a:rPr>
+              <a:t>じゅうぶん</a:t>
+            </a:r>
+          </a:p>
+        </p:txBody>
+      </p:sp>
     </p:spTree>
     <p:extLst>
       <p:ext uri="{BB962C8B-B14F-4D97-AF65-F5344CB8AC3E}">

</xml_diff>

<commit_message>
update 22_12 listen 1-4 & 1-5
</commit_message>
<xml_diff>
--- a/LISTEN/2_22_12.pptx
+++ b/LISTEN/2_22_12.pptx
@@ -9,6 +9,7 @@
     <p:sldId id="258" r:id="rId3"/>
     <p:sldId id="259" r:id="rId4"/>
     <p:sldId id="260" r:id="rId5"/>
+    <p:sldId id="261" r:id="rId6"/>
   </p:sldIdLst>
   <p:sldSz cx="12192000" cy="6858000"/>
   <p:notesSz cx="6858000" cy="9144000"/>
@@ -5824,10 +5825,1660 @@
           </a:prstGeom>
         </p:spPr>
       </p:pic>
+      <p:sp>
+        <p:nvSpPr>
+          <p:cNvPr id="5" name="文本框 4">
+            <a:extLst>
+              <a:ext uri="{FF2B5EF4-FFF2-40B4-BE49-F238E27FC236}">
+                <a16:creationId xmlns:a16="http://schemas.microsoft.com/office/drawing/2014/main" id="{31C332B7-9F93-4DB3-AF89-77240E472D03}"/>
+              </a:ext>
+            </a:extLst>
+          </p:cNvPr>
+          <p:cNvSpPr txBox="1"/>
+          <p:nvPr/>
+        </p:nvSpPr>
+        <p:spPr>
+          <a:xfrm>
+            <a:off x="1135027" y="1925898"/>
+            <a:ext cx="1140342" cy="307777"/>
+          </a:xfrm>
+          <a:prstGeom prst="rect">
+            <a:avLst/>
+          </a:prstGeom>
+          <a:noFill/>
+        </p:spPr>
+        <p:txBody>
+          <a:bodyPr wrap="square">
+            <a:spAutoFit/>
+          </a:bodyPr>
+          <a:lstStyle/>
+          <a:p>
+            <a:r>
+              <a:rPr lang="zh-CN" altLang="en-US" sz="1400" dirty="0">
+                <a:solidFill>
+                  <a:schemeClr val="accent1"/>
+                </a:solidFill>
+              </a:rPr>
+              <a:t>たしか</a:t>
+            </a:r>
+          </a:p>
+        </p:txBody>
+      </p:sp>
+      <p:sp>
+        <p:nvSpPr>
+          <p:cNvPr id="6" name="文本框 5">
+            <a:extLst>
+              <a:ext uri="{FF2B5EF4-FFF2-40B4-BE49-F238E27FC236}">
+                <a16:creationId xmlns:a16="http://schemas.microsoft.com/office/drawing/2014/main" id="{03820FA9-B986-472A-9BF8-A6C191757D58}"/>
+              </a:ext>
+            </a:extLst>
+          </p:cNvPr>
+          <p:cNvSpPr txBox="1"/>
+          <p:nvPr/>
+        </p:nvSpPr>
+        <p:spPr>
+          <a:xfrm>
+            <a:off x="1427420" y="2313985"/>
+            <a:ext cx="1140342" cy="369332"/>
+          </a:xfrm>
+          <a:prstGeom prst="rect">
+            <a:avLst/>
+          </a:prstGeom>
+          <a:noFill/>
+        </p:spPr>
+        <p:txBody>
+          <a:bodyPr wrap="square">
+            <a:spAutoFit/>
+          </a:bodyPr>
+          <a:lstStyle/>
+          <a:p>
+            <a:r>
+              <a:rPr lang="zh-CN" altLang="en-US" dirty="0">
+                <a:solidFill>
+                  <a:schemeClr val="accent1"/>
+                </a:solidFill>
+              </a:rPr>
+              <a:t>きんぎょ</a:t>
+            </a:r>
+          </a:p>
+        </p:txBody>
+      </p:sp>
+      <p:sp>
+        <p:nvSpPr>
+          <p:cNvPr id="8" name="文本框 7">
+            <a:extLst>
+              <a:ext uri="{FF2B5EF4-FFF2-40B4-BE49-F238E27FC236}">
+                <a16:creationId xmlns:a16="http://schemas.microsoft.com/office/drawing/2014/main" id="{B778ECE5-229F-4B06-85AC-C98F1FD5C88F}"/>
+              </a:ext>
+            </a:extLst>
+          </p:cNvPr>
+          <p:cNvSpPr txBox="1"/>
+          <p:nvPr/>
+        </p:nvSpPr>
+        <p:spPr>
+          <a:xfrm>
+            <a:off x="1965692" y="1863221"/>
+            <a:ext cx="511694" cy="369332"/>
+          </a:xfrm>
+          <a:prstGeom prst="rect">
+            <a:avLst/>
+          </a:prstGeom>
+          <a:noFill/>
+        </p:spPr>
+        <p:txBody>
+          <a:bodyPr wrap="square">
+            <a:spAutoFit/>
+          </a:bodyPr>
+          <a:lstStyle/>
+          <a:p>
+            <a:r>
+              <a:rPr lang="zh-CN" altLang="en-US" dirty="0">
+                <a:solidFill>
+                  <a:schemeClr val="accent1"/>
+                </a:solidFill>
+              </a:rPr>
+              <a:t>か</a:t>
+            </a:r>
+          </a:p>
+        </p:txBody>
+      </p:sp>
+      <p:sp>
+        <p:nvSpPr>
+          <p:cNvPr id="10" name="文本框 9">
+            <a:extLst>
+              <a:ext uri="{FF2B5EF4-FFF2-40B4-BE49-F238E27FC236}">
+                <a16:creationId xmlns:a16="http://schemas.microsoft.com/office/drawing/2014/main" id="{BB2F5F3D-B598-4BB2-A14E-AC21AD54DEA9}"/>
+              </a:ext>
+            </a:extLst>
+          </p:cNvPr>
+          <p:cNvSpPr txBox="1"/>
+          <p:nvPr/>
+        </p:nvSpPr>
+        <p:spPr>
+          <a:xfrm>
+            <a:off x="6334346" y="2819032"/>
+            <a:ext cx="725672" cy="369332"/>
+          </a:xfrm>
+          <a:prstGeom prst="rect">
+            <a:avLst/>
+          </a:prstGeom>
+          <a:noFill/>
+        </p:spPr>
+        <p:txBody>
+          <a:bodyPr wrap="square">
+            <a:spAutoFit/>
+          </a:bodyPr>
+          <a:lstStyle/>
+          <a:p>
+            <a:r>
+              <a:rPr lang="zh-CN" altLang="en-US" dirty="0">
+                <a:solidFill>
+                  <a:schemeClr val="accent1"/>
+                </a:solidFill>
+              </a:rPr>
+              <a:t>よご</a:t>
+            </a:r>
+          </a:p>
+        </p:txBody>
+      </p:sp>
+      <p:sp>
+        <p:nvSpPr>
+          <p:cNvPr id="11" name="文本框 10">
+            <a:extLst>
+              <a:ext uri="{FF2B5EF4-FFF2-40B4-BE49-F238E27FC236}">
+                <a16:creationId xmlns:a16="http://schemas.microsoft.com/office/drawing/2014/main" id="{FA8E4573-CED4-44CE-A31C-9B9ABBCA49D4}"/>
+              </a:ext>
+            </a:extLst>
+          </p:cNvPr>
+          <p:cNvSpPr txBox="1"/>
+          <p:nvPr/>
+        </p:nvSpPr>
+        <p:spPr>
+          <a:xfrm>
+            <a:off x="3881769" y="3715711"/>
+            <a:ext cx="725672" cy="369332"/>
+          </a:xfrm>
+          <a:prstGeom prst="rect">
+            <a:avLst/>
+          </a:prstGeom>
+          <a:noFill/>
+        </p:spPr>
+        <p:txBody>
+          <a:bodyPr wrap="square">
+            <a:spAutoFit/>
+          </a:bodyPr>
+          <a:lstStyle/>
+          <a:p>
+            <a:r>
+              <a:rPr lang="zh-CN" altLang="en-US" dirty="0">
+                <a:solidFill>
+                  <a:schemeClr val="accent1"/>
+                </a:solidFill>
+              </a:rPr>
+              <a:t>よご</a:t>
+            </a:r>
+          </a:p>
+        </p:txBody>
+      </p:sp>
+      <p:sp>
+        <p:nvSpPr>
+          <p:cNvPr id="12" name="文本框 11">
+            <a:extLst>
+              <a:ext uri="{FF2B5EF4-FFF2-40B4-BE49-F238E27FC236}">
+                <a16:creationId xmlns:a16="http://schemas.microsoft.com/office/drawing/2014/main" id="{3818E94F-0E02-4CD9-A720-115CAFC0E29A}"/>
+              </a:ext>
+            </a:extLst>
+          </p:cNvPr>
+          <p:cNvSpPr txBox="1"/>
+          <p:nvPr/>
+        </p:nvSpPr>
+        <p:spPr>
+          <a:xfrm>
+            <a:off x="7741388" y="4640743"/>
+            <a:ext cx="725672" cy="369332"/>
+          </a:xfrm>
+          <a:prstGeom prst="rect">
+            <a:avLst/>
+          </a:prstGeom>
+          <a:noFill/>
+        </p:spPr>
+        <p:txBody>
+          <a:bodyPr wrap="square">
+            <a:spAutoFit/>
+          </a:bodyPr>
+          <a:lstStyle/>
+          <a:p>
+            <a:r>
+              <a:rPr lang="zh-CN" altLang="en-US" dirty="0">
+                <a:solidFill>
+                  <a:schemeClr val="accent1"/>
+                </a:solidFill>
+              </a:rPr>
+              <a:t>よご</a:t>
+            </a:r>
+          </a:p>
+        </p:txBody>
+      </p:sp>
+      <p:sp>
+        <p:nvSpPr>
+          <p:cNvPr id="14" name="文本框 13">
+            <a:extLst>
+              <a:ext uri="{FF2B5EF4-FFF2-40B4-BE49-F238E27FC236}">
+                <a16:creationId xmlns:a16="http://schemas.microsoft.com/office/drawing/2014/main" id="{283D60EF-7935-44FA-B99E-23A32CE85F40}"/>
+              </a:ext>
+            </a:extLst>
+          </p:cNvPr>
+          <p:cNvSpPr txBox="1"/>
+          <p:nvPr/>
+        </p:nvSpPr>
+        <p:spPr>
+          <a:xfrm>
+            <a:off x="236574" y="3729340"/>
+            <a:ext cx="725672" cy="369332"/>
+          </a:xfrm>
+          <a:prstGeom prst="rect">
+            <a:avLst/>
+          </a:prstGeom>
+          <a:noFill/>
+        </p:spPr>
+        <p:txBody>
+          <a:bodyPr wrap="square">
+            <a:spAutoFit/>
+          </a:bodyPr>
+          <a:lstStyle/>
+          <a:p>
+            <a:r>
+              <a:rPr lang="zh-CN" altLang="en-US" dirty="0">
+                <a:solidFill>
+                  <a:schemeClr val="accent1"/>
+                </a:solidFill>
+              </a:rPr>
+              <a:t>みず</a:t>
+            </a:r>
+          </a:p>
+        </p:txBody>
+      </p:sp>
+      <p:sp>
+        <p:nvSpPr>
+          <p:cNvPr id="16" name="文本框 15">
+            <a:extLst>
+              <a:ext uri="{FF2B5EF4-FFF2-40B4-BE49-F238E27FC236}">
+                <a16:creationId xmlns:a16="http://schemas.microsoft.com/office/drawing/2014/main" id="{3BB77CC6-CCED-4993-99E2-9CDAF479E979}"/>
+              </a:ext>
+            </a:extLst>
+          </p:cNvPr>
+          <p:cNvSpPr txBox="1"/>
+          <p:nvPr/>
+        </p:nvSpPr>
+        <p:spPr>
+          <a:xfrm>
+            <a:off x="962246" y="3729340"/>
+            <a:ext cx="855921" cy="369332"/>
+          </a:xfrm>
+          <a:prstGeom prst="rect">
+            <a:avLst/>
+          </a:prstGeom>
+          <a:noFill/>
+        </p:spPr>
+        <p:txBody>
+          <a:bodyPr wrap="square">
+            <a:spAutoFit/>
+          </a:bodyPr>
+          <a:lstStyle/>
+          <a:p>
+            <a:r>
+              <a:rPr lang="zh-CN" altLang="en-US" dirty="0">
+                <a:solidFill>
+                  <a:schemeClr val="accent1"/>
+                </a:solidFill>
+              </a:rPr>
+              <a:t>かい</a:t>
+            </a:r>
+          </a:p>
+        </p:txBody>
+      </p:sp>
+      <p:sp>
+        <p:nvSpPr>
+          <p:cNvPr id="18" name="文本框 17">
+            <a:extLst>
+              <a:ext uri="{FF2B5EF4-FFF2-40B4-BE49-F238E27FC236}">
+                <a16:creationId xmlns:a16="http://schemas.microsoft.com/office/drawing/2014/main" id="{0EC2490B-C87F-4DF1-8CE7-1D894BB334F1}"/>
+              </a:ext>
+            </a:extLst>
+          </p:cNvPr>
+          <p:cNvSpPr txBox="1"/>
+          <p:nvPr/>
+        </p:nvSpPr>
+        <p:spPr>
+          <a:xfrm>
+            <a:off x="730989" y="2795719"/>
+            <a:ext cx="855921" cy="369332"/>
+          </a:xfrm>
+          <a:prstGeom prst="rect">
+            <a:avLst/>
+          </a:prstGeom>
+          <a:noFill/>
+        </p:spPr>
+        <p:txBody>
+          <a:bodyPr wrap="square">
+            <a:spAutoFit/>
+          </a:bodyPr>
+          <a:lstStyle/>
+          <a:p>
+            <a:r>
+              <a:rPr lang="zh-CN" altLang="en-US" dirty="0">
+                <a:solidFill>
+                  <a:schemeClr val="accent1"/>
+                </a:solidFill>
+              </a:rPr>
+              <a:t>にか</a:t>
+            </a:r>
+          </a:p>
+        </p:txBody>
+      </p:sp>
+      <p:sp>
+        <p:nvSpPr>
+          <p:cNvPr id="20" name="文本框 19">
+            <a:extLst>
+              <a:ext uri="{FF2B5EF4-FFF2-40B4-BE49-F238E27FC236}">
+                <a16:creationId xmlns:a16="http://schemas.microsoft.com/office/drawing/2014/main" id="{F5DA055D-FD27-40CE-956A-87DD0E262165}"/>
+              </a:ext>
+            </a:extLst>
+          </p:cNvPr>
+          <p:cNvSpPr txBox="1"/>
+          <p:nvPr/>
+        </p:nvSpPr>
+        <p:spPr>
+          <a:xfrm>
+            <a:off x="4781993" y="5115664"/>
+            <a:ext cx="917058" cy="369332"/>
+          </a:xfrm>
+          <a:prstGeom prst="rect">
+            <a:avLst/>
+          </a:prstGeom>
+          <a:noFill/>
+        </p:spPr>
+        <p:txBody>
+          <a:bodyPr wrap="square">
+            <a:spAutoFit/>
+          </a:bodyPr>
+          <a:lstStyle/>
+          <a:p>
+            <a:r>
+              <a:rPr lang="zh-CN" altLang="en-US">
+                <a:solidFill>
+                  <a:schemeClr val="accent1"/>
+                </a:solidFill>
+              </a:rPr>
+              <a:t>えさ</a:t>
+            </a:r>
+            <a:endParaRPr lang="zh-CN" altLang="en-US" dirty="0">
+              <a:solidFill>
+                <a:schemeClr val="accent1"/>
+              </a:solidFill>
+            </a:endParaRPr>
+          </a:p>
+        </p:txBody>
+      </p:sp>
+      <p:sp>
+        <p:nvSpPr>
+          <p:cNvPr id="21" name="文本框 20">
+            <a:extLst>
+              <a:ext uri="{FF2B5EF4-FFF2-40B4-BE49-F238E27FC236}">
+                <a16:creationId xmlns:a16="http://schemas.microsoft.com/office/drawing/2014/main" id="{59F555D0-C05D-4B64-AE0F-182C01A4EB90}"/>
+              </a:ext>
+            </a:extLst>
+          </p:cNvPr>
+          <p:cNvSpPr txBox="1"/>
+          <p:nvPr/>
+        </p:nvSpPr>
+        <p:spPr>
+          <a:xfrm>
+            <a:off x="1427420" y="4640743"/>
+            <a:ext cx="917058" cy="369332"/>
+          </a:xfrm>
+          <a:prstGeom prst="rect">
+            <a:avLst/>
+          </a:prstGeom>
+          <a:noFill/>
+        </p:spPr>
+        <p:txBody>
+          <a:bodyPr wrap="square">
+            <a:spAutoFit/>
+          </a:bodyPr>
+          <a:lstStyle/>
+          <a:p>
+            <a:r>
+              <a:rPr lang="zh-CN" altLang="en-US">
+                <a:solidFill>
+                  <a:schemeClr val="accent1"/>
+                </a:solidFill>
+              </a:rPr>
+              <a:t>えさ</a:t>
+            </a:r>
+            <a:endParaRPr lang="zh-CN" altLang="en-US" dirty="0">
+              <a:solidFill>
+                <a:schemeClr val="accent1"/>
+              </a:solidFill>
+            </a:endParaRPr>
+          </a:p>
+        </p:txBody>
+      </p:sp>
+      <p:sp>
+        <p:nvSpPr>
+          <p:cNvPr id="23" name="文本框 22">
+            <a:extLst>
+              <a:ext uri="{FF2B5EF4-FFF2-40B4-BE49-F238E27FC236}">
+                <a16:creationId xmlns:a16="http://schemas.microsoft.com/office/drawing/2014/main" id="{A0384DD3-B6B8-492E-AE7C-61821BB46F3A}"/>
+              </a:ext>
+            </a:extLst>
+          </p:cNvPr>
+          <p:cNvSpPr txBox="1"/>
+          <p:nvPr/>
+        </p:nvSpPr>
+        <p:spPr>
+          <a:xfrm>
+            <a:off x="1733107" y="5010954"/>
+            <a:ext cx="1254642" cy="369332"/>
+          </a:xfrm>
+          <a:prstGeom prst="rect">
+            <a:avLst/>
+          </a:prstGeom>
+          <a:noFill/>
+        </p:spPr>
+        <p:txBody>
+          <a:bodyPr wrap="square">
+            <a:spAutoFit/>
+          </a:bodyPr>
+          <a:lstStyle/>
+          <a:p>
+            <a:r>
+              <a:rPr lang="zh-CN" altLang="en-US">
+                <a:solidFill>
+                  <a:schemeClr val="accent1"/>
+                </a:solidFill>
+              </a:rPr>
+              <a:t>りょう</a:t>
+            </a:r>
+            <a:endParaRPr lang="zh-CN" altLang="en-US" dirty="0">
+              <a:solidFill>
+                <a:schemeClr val="accent1"/>
+              </a:solidFill>
+            </a:endParaRPr>
+          </a:p>
+        </p:txBody>
+      </p:sp>
+      <p:sp>
+        <p:nvSpPr>
+          <p:cNvPr id="25" name="文本框 24">
+            <a:extLst>
+              <a:ext uri="{FF2B5EF4-FFF2-40B4-BE49-F238E27FC236}">
+                <a16:creationId xmlns:a16="http://schemas.microsoft.com/office/drawing/2014/main" id="{386CBDDF-396B-4B17-AEDD-6D4B7520850A}"/>
+              </a:ext>
+            </a:extLst>
+          </p:cNvPr>
+          <p:cNvSpPr txBox="1"/>
+          <p:nvPr/>
+        </p:nvSpPr>
+        <p:spPr>
+          <a:xfrm>
+            <a:off x="3293436" y="4639339"/>
+            <a:ext cx="917058" cy="369332"/>
+          </a:xfrm>
+          <a:prstGeom prst="rect">
+            <a:avLst/>
+          </a:prstGeom>
+          <a:noFill/>
+        </p:spPr>
+        <p:txBody>
+          <a:bodyPr wrap="square">
+            <a:spAutoFit/>
+          </a:bodyPr>
+          <a:lstStyle/>
+          <a:p>
+            <a:r>
+              <a:rPr lang="zh-CN" altLang="en-US">
+                <a:solidFill>
+                  <a:schemeClr val="accent1"/>
+                </a:solidFill>
+              </a:rPr>
+              <a:t>ひあ</a:t>
+            </a:r>
+            <a:endParaRPr lang="zh-CN" altLang="en-US" dirty="0">
+              <a:solidFill>
+                <a:schemeClr val="accent1"/>
+              </a:solidFill>
+            </a:endParaRPr>
+          </a:p>
+        </p:txBody>
+      </p:sp>
+      <p:sp>
+        <p:nvSpPr>
+          <p:cNvPr id="27" name="文本框 26">
+            <a:extLst>
+              <a:ext uri="{FF2B5EF4-FFF2-40B4-BE49-F238E27FC236}">
+                <a16:creationId xmlns:a16="http://schemas.microsoft.com/office/drawing/2014/main" id="{135F2164-8E4C-4399-A484-7044375852B3}"/>
+              </a:ext>
+            </a:extLst>
+          </p:cNvPr>
+          <p:cNvSpPr txBox="1"/>
+          <p:nvPr/>
+        </p:nvSpPr>
+        <p:spPr>
+          <a:xfrm>
+            <a:off x="8152958" y="5032220"/>
+            <a:ext cx="1558555" cy="369332"/>
+          </a:xfrm>
+          <a:prstGeom prst="rect">
+            <a:avLst/>
+          </a:prstGeom>
+          <a:noFill/>
+        </p:spPr>
+        <p:txBody>
+          <a:bodyPr wrap="square">
+            <a:spAutoFit/>
+          </a:bodyPr>
+          <a:lstStyle/>
+          <a:p>
+            <a:r>
+              <a:rPr lang="zh-CN" altLang="en-US" dirty="0">
+                <a:solidFill>
+                  <a:schemeClr val="accent1"/>
+                </a:solidFill>
+              </a:rPr>
+              <a:t>えいきょう</a:t>
+            </a:r>
+          </a:p>
+        </p:txBody>
+      </p:sp>
+      <p:sp>
+        <p:nvSpPr>
+          <p:cNvPr id="29" name="文本框 28">
+            <a:extLst>
+              <a:ext uri="{FF2B5EF4-FFF2-40B4-BE49-F238E27FC236}">
+                <a16:creationId xmlns:a16="http://schemas.microsoft.com/office/drawing/2014/main" id="{0B32DA47-3CC2-407C-8D68-62A195C83BA2}"/>
+              </a:ext>
+            </a:extLst>
+          </p:cNvPr>
+          <p:cNvSpPr txBox="1"/>
+          <p:nvPr/>
+        </p:nvSpPr>
+        <p:spPr>
+          <a:xfrm>
+            <a:off x="6697182" y="5044257"/>
+            <a:ext cx="725672" cy="369332"/>
+          </a:xfrm>
+          <a:prstGeom prst="rect">
+            <a:avLst/>
+          </a:prstGeom>
+          <a:noFill/>
+        </p:spPr>
+        <p:txBody>
+          <a:bodyPr wrap="square">
+            <a:spAutoFit/>
+          </a:bodyPr>
+          <a:lstStyle/>
+          <a:p>
+            <a:r>
+              <a:rPr lang="zh-CN" altLang="en-US" dirty="0">
+                <a:solidFill>
+                  <a:schemeClr val="accent1"/>
+                </a:solidFill>
+              </a:rPr>
+              <a:t>とお</a:t>
+            </a:r>
+          </a:p>
+        </p:txBody>
+      </p:sp>
+      <p:sp>
+        <p:nvSpPr>
+          <p:cNvPr id="31" name="文本框 30">
+            <a:extLst>
+              <a:ext uri="{FF2B5EF4-FFF2-40B4-BE49-F238E27FC236}">
+                <a16:creationId xmlns:a16="http://schemas.microsoft.com/office/drawing/2014/main" id="{D174660B-17C2-483F-B605-E1C62DC8F425}"/>
+              </a:ext>
+            </a:extLst>
+          </p:cNvPr>
+          <p:cNvSpPr txBox="1"/>
+          <p:nvPr/>
+        </p:nvSpPr>
+        <p:spPr>
+          <a:xfrm>
+            <a:off x="835983" y="5552146"/>
+            <a:ext cx="1161608" cy="369332"/>
+          </a:xfrm>
+          <a:prstGeom prst="rect">
+            <a:avLst/>
+          </a:prstGeom>
+          <a:noFill/>
+        </p:spPr>
+        <p:txBody>
+          <a:bodyPr wrap="square">
+            <a:spAutoFit/>
+          </a:bodyPr>
+          <a:lstStyle/>
+          <a:p>
+            <a:r>
+              <a:rPr lang="zh-CN" altLang="en-US" dirty="0">
+                <a:solidFill>
+                  <a:schemeClr val="accent1"/>
+                </a:solidFill>
+              </a:rPr>
+              <a:t>げんかん</a:t>
+            </a:r>
+          </a:p>
+        </p:txBody>
+      </p:sp>
+      <p:sp>
+        <p:nvSpPr>
+          <p:cNvPr id="33" name="文本框 32">
+            <a:extLst>
+              <a:ext uri="{FF2B5EF4-FFF2-40B4-BE49-F238E27FC236}">
+                <a16:creationId xmlns:a16="http://schemas.microsoft.com/office/drawing/2014/main" id="{4762787F-41B9-4E53-A64B-F83BE69C6020}"/>
+              </a:ext>
+            </a:extLst>
+          </p:cNvPr>
+          <p:cNvSpPr txBox="1"/>
+          <p:nvPr/>
+        </p:nvSpPr>
+        <p:spPr>
+          <a:xfrm>
+            <a:off x="6217389" y="5552146"/>
+            <a:ext cx="725672" cy="369332"/>
+          </a:xfrm>
+          <a:prstGeom prst="rect">
+            <a:avLst/>
+          </a:prstGeom>
+          <a:noFill/>
+        </p:spPr>
+        <p:txBody>
+          <a:bodyPr wrap="square">
+            <a:spAutoFit/>
+          </a:bodyPr>
+          <a:lstStyle/>
+          <a:p>
+            <a:r>
+              <a:rPr lang="zh-CN" altLang="en-US">
+                <a:solidFill>
+                  <a:schemeClr val="accent1"/>
+                </a:solidFill>
+              </a:rPr>
+              <a:t>すく</a:t>
+            </a:r>
+            <a:endParaRPr lang="zh-CN" altLang="en-US" dirty="0">
+              <a:solidFill>
+                <a:schemeClr val="accent1"/>
+              </a:solidFill>
+            </a:endParaRPr>
+          </a:p>
+        </p:txBody>
+      </p:sp>
+      <p:sp>
+        <p:nvSpPr>
+          <p:cNvPr id="34" name="文本框 33">
+            <a:extLst>
+              <a:ext uri="{FF2B5EF4-FFF2-40B4-BE49-F238E27FC236}">
+                <a16:creationId xmlns:a16="http://schemas.microsoft.com/office/drawing/2014/main" id="{992378EB-52DF-4212-9DAF-2304837CD0F4}"/>
+              </a:ext>
+            </a:extLst>
+          </p:cNvPr>
+          <p:cNvSpPr txBox="1"/>
+          <p:nvPr/>
+        </p:nvSpPr>
+        <p:spPr>
+          <a:xfrm>
+            <a:off x="8283649" y="5484996"/>
+            <a:ext cx="725672" cy="369332"/>
+          </a:xfrm>
+          <a:prstGeom prst="rect">
+            <a:avLst/>
+          </a:prstGeom>
+          <a:noFill/>
+        </p:spPr>
+        <p:txBody>
+          <a:bodyPr wrap="square">
+            <a:spAutoFit/>
+          </a:bodyPr>
+          <a:lstStyle/>
+          <a:p>
+            <a:r>
+              <a:rPr lang="zh-CN" altLang="en-US">
+                <a:solidFill>
+                  <a:schemeClr val="accent1"/>
+                </a:solidFill>
+              </a:rPr>
+              <a:t>すく</a:t>
+            </a:r>
+            <a:endParaRPr lang="zh-CN" altLang="en-US" dirty="0">
+              <a:solidFill>
+                <a:schemeClr val="accent1"/>
+              </a:solidFill>
+            </a:endParaRPr>
+          </a:p>
+        </p:txBody>
+      </p:sp>
     </p:spTree>
     <p:extLst>
       <p:ext uri="{BB962C8B-B14F-4D97-AF65-F5344CB8AC3E}">
         <p14:creationId xmlns:p14="http://schemas.microsoft.com/office/powerpoint/2010/main" val="632401291"/>
+      </p:ext>
+    </p:extLst>
+  </p:cSld>
+  <p:clrMapOvr>
+    <a:masterClrMapping/>
+  </p:clrMapOvr>
+</p:sld>
+</file>
+
+<file path=ppt/slides/slide5.xml><?xml version="1.0" encoding="utf-8"?>
+<p:sld xmlns:a="http://schemas.openxmlformats.org/drawingml/2006/main" xmlns:r="http://schemas.openxmlformats.org/officeDocument/2006/relationships" xmlns:p="http://schemas.openxmlformats.org/presentationml/2006/main">
+  <p:cSld>
+    <p:spTree>
+      <p:nvGrpSpPr>
+        <p:cNvPr id="1" name=""/>
+        <p:cNvGrpSpPr/>
+        <p:nvPr/>
+      </p:nvGrpSpPr>
+      <p:grpSpPr>
+        <a:xfrm>
+          <a:off x="0" y="0"/>
+          <a:ext cx="0" cy="0"/>
+          <a:chOff x="0" y="0"/>
+          <a:chExt cx="0" cy="0"/>
+        </a:xfrm>
+      </p:grpSpPr>
+      <p:pic>
+        <p:nvPicPr>
+          <p:cNvPr id="4" name="图片 3">
+            <a:extLst>
+              <a:ext uri="{FF2B5EF4-FFF2-40B4-BE49-F238E27FC236}">
+                <a16:creationId xmlns:a16="http://schemas.microsoft.com/office/drawing/2014/main" id="{C19B88C8-488F-4F26-BAD1-4F601D6F5C52}"/>
+              </a:ext>
+            </a:extLst>
+          </p:cNvPr>
+          <p:cNvPicPr>
+            <a:picLocks noChangeAspect="1"/>
+          </p:cNvPicPr>
+          <p:nvPr/>
+        </p:nvPicPr>
+        <p:blipFill>
+          <a:blip r:embed="rId2"/>
+          <a:stretch>
+            <a:fillRect/>
+          </a:stretch>
+        </p:blipFill>
+        <p:spPr>
+          <a:xfrm>
+            <a:off x="63795" y="504547"/>
+            <a:ext cx="12064409" cy="5848905"/>
+          </a:xfrm>
+          <a:prstGeom prst="rect">
+            <a:avLst/>
+          </a:prstGeom>
+        </p:spPr>
+      </p:pic>
+      <p:sp>
+        <p:nvSpPr>
+          <p:cNvPr id="6" name="文本框 5">
+            <a:extLst>
+              <a:ext uri="{FF2B5EF4-FFF2-40B4-BE49-F238E27FC236}">
+                <a16:creationId xmlns:a16="http://schemas.microsoft.com/office/drawing/2014/main" id="{40208B6C-A0D3-4A97-B46E-51B2F49547B5}"/>
+              </a:ext>
+            </a:extLst>
+          </p:cNvPr>
+          <p:cNvSpPr txBox="1"/>
+          <p:nvPr/>
+        </p:nvSpPr>
+        <p:spPr>
+          <a:xfrm>
+            <a:off x="220625" y="1925896"/>
+            <a:ext cx="1331728" cy="369332"/>
+          </a:xfrm>
+          <a:prstGeom prst="rect">
+            <a:avLst/>
+          </a:prstGeom>
+          <a:noFill/>
+        </p:spPr>
+        <p:txBody>
+          <a:bodyPr wrap="square">
+            <a:spAutoFit/>
+          </a:bodyPr>
+          <a:lstStyle/>
+          <a:p>
+            <a:r>
+              <a:rPr lang="zh-CN" altLang="en-US" dirty="0">
+                <a:solidFill>
+                  <a:schemeClr val="accent1"/>
+                </a:solidFill>
+              </a:rPr>
+              <a:t>なかやま</a:t>
+            </a:r>
+          </a:p>
+        </p:txBody>
+      </p:sp>
+      <p:sp>
+        <p:nvSpPr>
+          <p:cNvPr id="8" name="文本框 7">
+            <a:extLst>
+              <a:ext uri="{FF2B5EF4-FFF2-40B4-BE49-F238E27FC236}">
+                <a16:creationId xmlns:a16="http://schemas.microsoft.com/office/drawing/2014/main" id="{C52A25CC-9E05-4AE3-B339-28DF77691621}"/>
+              </a:ext>
+            </a:extLst>
+          </p:cNvPr>
+          <p:cNvSpPr txBox="1"/>
+          <p:nvPr/>
+        </p:nvSpPr>
+        <p:spPr>
+          <a:xfrm>
+            <a:off x="886489" y="2295228"/>
+            <a:ext cx="1608174" cy="369332"/>
+          </a:xfrm>
+          <a:prstGeom prst="rect">
+            <a:avLst/>
+          </a:prstGeom>
+          <a:noFill/>
+        </p:spPr>
+        <p:txBody>
+          <a:bodyPr wrap="square">
+            <a:spAutoFit/>
+          </a:bodyPr>
+          <a:lstStyle/>
+          <a:p>
+            <a:r>
+              <a:rPr lang="zh-CN" altLang="en-US" dirty="0">
+                <a:solidFill>
+                  <a:schemeClr val="accent1"/>
+                </a:solidFill>
+              </a:rPr>
+              <a:t>しんせいひん</a:t>
+            </a:r>
+          </a:p>
+        </p:txBody>
+      </p:sp>
+      <p:sp>
+        <p:nvSpPr>
+          <p:cNvPr id="10" name="文本框 9">
+            <a:extLst>
+              <a:ext uri="{FF2B5EF4-FFF2-40B4-BE49-F238E27FC236}">
+                <a16:creationId xmlns:a16="http://schemas.microsoft.com/office/drawing/2014/main" id="{8D7B7D9E-F3A9-4181-AC32-9124D0529D39}"/>
+              </a:ext>
+            </a:extLst>
+          </p:cNvPr>
+          <p:cNvSpPr txBox="1"/>
+          <p:nvPr/>
+        </p:nvSpPr>
+        <p:spPr>
+          <a:xfrm>
+            <a:off x="1709183" y="1925896"/>
+            <a:ext cx="1703868" cy="369332"/>
+          </a:xfrm>
+          <a:prstGeom prst="rect">
+            <a:avLst/>
+          </a:prstGeom>
+          <a:noFill/>
+        </p:spPr>
+        <p:txBody>
+          <a:bodyPr wrap="square">
+            <a:spAutoFit/>
+          </a:bodyPr>
+          <a:lstStyle/>
+          <a:p>
+            <a:r>
+              <a:rPr lang="zh-CN" altLang="en-US" dirty="0">
+                <a:solidFill>
+                  <a:schemeClr val="accent1"/>
+                </a:solidFill>
+              </a:rPr>
+              <a:t>せんたくき</a:t>
+            </a:r>
+          </a:p>
+        </p:txBody>
+      </p:sp>
+      <p:sp>
+        <p:nvSpPr>
+          <p:cNvPr id="12" name="文本框 11">
+            <a:extLst>
+              <a:ext uri="{FF2B5EF4-FFF2-40B4-BE49-F238E27FC236}">
+                <a16:creationId xmlns:a16="http://schemas.microsoft.com/office/drawing/2014/main" id="{20022903-2AFA-4E3A-B77E-AAA69E5063C0}"/>
+              </a:ext>
+            </a:extLst>
+          </p:cNvPr>
+          <p:cNvSpPr txBox="1"/>
+          <p:nvPr/>
+        </p:nvSpPr>
+        <p:spPr>
+          <a:xfrm>
+            <a:off x="1858039" y="2848404"/>
+            <a:ext cx="1087180" cy="307777"/>
+          </a:xfrm>
+          <a:prstGeom prst="rect">
+            <a:avLst/>
+          </a:prstGeom>
+          <a:noFill/>
+        </p:spPr>
+        <p:txBody>
+          <a:bodyPr wrap="square">
+            <a:spAutoFit/>
+          </a:bodyPr>
+          <a:lstStyle/>
+          <a:p>
+            <a:r>
+              <a:rPr lang="zh-CN" altLang="en-US" sz="1400" dirty="0">
+                <a:solidFill>
+                  <a:schemeClr val="accent1"/>
+                </a:solidFill>
+              </a:rPr>
+              <a:t>しょうさい</a:t>
+            </a:r>
+          </a:p>
+        </p:txBody>
+      </p:sp>
+      <p:sp>
+        <p:nvSpPr>
+          <p:cNvPr id="14" name="文本框 13">
+            <a:extLst>
+              <a:ext uri="{FF2B5EF4-FFF2-40B4-BE49-F238E27FC236}">
+                <a16:creationId xmlns:a16="http://schemas.microsoft.com/office/drawing/2014/main" id="{F8484C11-2872-460A-935E-F839F0FDBB53}"/>
+              </a:ext>
+            </a:extLst>
+          </p:cNvPr>
+          <p:cNvSpPr txBox="1"/>
+          <p:nvPr/>
+        </p:nvSpPr>
+        <p:spPr>
+          <a:xfrm>
+            <a:off x="2401629" y="3217736"/>
+            <a:ext cx="1181543" cy="276999"/>
+          </a:xfrm>
+          <a:prstGeom prst="rect">
+            <a:avLst/>
+          </a:prstGeom>
+          <a:noFill/>
+        </p:spPr>
+        <p:txBody>
+          <a:bodyPr wrap="square">
+            <a:spAutoFit/>
+          </a:bodyPr>
+          <a:lstStyle/>
+          <a:p>
+            <a:r>
+              <a:rPr lang="zh-CN" altLang="en-US" sz="1200" dirty="0">
+                <a:solidFill>
+                  <a:schemeClr val="accent1"/>
+                </a:solidFill>
+              </a:rPr>
+              <a:t>とりあつかい</a:t>
+            </a:r>
+          </a:p>
+        </p:txBody>
+      </p:sp>
+      <p:sp>
+        <p:nvSpPr>
+          <p:cNvPr id="16" name="文本框 15">
+            <a:extLst>
+              <a:ext uri="{FF2B5EF4-FFF2-40B4-BE49-F238E27FC236}">
+                <a16:creationId xmlns:a16="http://schemas.microsoft.com/office/drawing/2014/main" id="{855606E4-219F-4ADC-8976-95B9ACF1767B}"/>
+              </a:ext>
+            </a:extLst>
+          </p:cNvPr>
+          <p:cNvSpPr txBox="1"/>
+          <p:nvPr/>
+        </p:nvSpPr>
+        <p:spPr>
+          <a:xfrm>
+            <a:off x="2786395" y="2848404"/>
+            <a:ext cx="1181543" cy="523220"/>
+          </a:xfrm>
+          <a:prstGeom prst="rect">
+            <a:avLst/>
+          </a:prstGeom>
+          <a:noFill/>
+        </p:spPr>
+        <p:txBody>
+          <a:bodyPr wrap="square">
+            <a:spAutoFit/>
+          </a:bodyPr>
+          <a:lstStyle/>
+          <a:p>
+            <a:r>
+              <a:rPr lang="zh-CN" altLang="en-US" sz="1400" dirty="0">
+                <a:solidFill>
+                  <a:schemeClr val="accent1"/>
+                </a:solidFill>
+              </a:rPr>
+              <a:t>せつめいしょ</a:t>
+            </a:r>
+          </a:p>
+        </p:txBody>
+      </p:sp>
+      <p:sp>
+        <p:nvSpPr>
+          <p:cNvPr id="18" name="文本框 17">
+            <a:extLst>
+              <a:ext uri="{FF2B5EF4-FFF2-40B4-BE49-F238E27FC236}">
+                <a16:creationId xmlns:a16="http://schemas.microsoft.com/office/drawing/2014/main" id="{8383B9D1-AB7A-4B8E-AF0E-36A7C64744BF}"/>
+              </a:ext>
+            </a:extLst>
+          </p:cNvPr>
+          <p:cNvSpPr txBox="1"/>
+          <p:nvPr/>
+        </p:nvSpPr>
+        <p:spPr>
+          <a:xfrm>
+            <a:off x="3466214" y="3186958"/>
+            <a:ext cx="1303818" cy="369332"/>
+          </a:xfrm>
+          <a:prstGeom prst="rect">
+            <a:avLst/>
+          </a:prstGeom>
+          <a:noFill/>
+        </p:spPr>
+        <p:txBody>
+          <a:bodyPr wrap="square">
+            <a:spAutoFit/>
+          </a:bodyPr>
+          <a:lstStyle/>
+          <a:p>
+            <a:r>
+              <a:rPr lang="zh-CN" altLang="en-US" dirty="0">
+                <a:solidFill>
+                  <a:schemeClr val="accent1"/>
+                </a:solidFill>
+              </a:rPr>
+              <a:t>かんたん</a:t>
+            </a:r>
+          </a:p>
+        </p:txBody>
+      </p:sp>
+      <p:sp>
+        <p:nvSpPr>
+          <p:cNvPr id="20" name="文本框 19">
+            <a:extLst>
+              <a:ext uri="{FF2B5EF4-FFF2-40B4-BE49-F238E27FC236}">
+                <a16:creationId xmlns:a16="http://schemas.microsoft.com/office/drawing/2014/main" id="{500E588C-389C-41E2-A187-719D0F1A7A49}"/>
+              </a:ext>
+            </a:extLst>
+          </p:cNvPr>
+          <p:cNvSpPr txBox="1"/>
+          <p:nvPr/>
+        </p:nvSpPr>
+        <p:spPr>
+          <a:xfrm>
+            <a:off x="3976466" y="2755210"/>
+            <a:ext cx="919828" cy="369332"/>
+          </a:xfrm>
+          <a:prstGeom prst="rect">
+            <a:avLst/>
+          </a:prstGeom>
+          <a:noFill/>
+        </p:spPr>
+        <p:txBody>
+          <a:bodyPr wrap="square">
+            <a:spAutoFit/>
+          </a:bodyPr>
+          <a:lstStyle/>
+          <a:p>
+            <a:r>
+              <a:rPr lang="zh-CN" altLang="en-US" dirty="0">
+                <a:solidFill>
+                  <a:schemeClr val="accent1"/>
+                </a:solidFill>
+              </a:rPr>
+              <a:t>かんい</a:t>
+            </a:r>
+          </a:p>
+        </p:txBody>
+      </p:sp>
+      <p:sp>
+        <p:nvSpPr>
+          <p:cNvPr id="22" name="文本框 21">
+            <a:extLst>
+              <a:ext uri="{FF2B5EF4-FFF2-40B4-BE49-F238E27FC236}">
+                <a16:creationId xmlns:a16="http://schemas.microsoft.com/office/drawing/2014/main" id="{564629AD-6EFD-4575-9A44-147764BE3456}"/>
+              </a:ext>
+            </a:extLst>
+          </p:cNvPr>
+          <p:cNvSpPr txBox="1"/>
+          <p:nvPr/>
+        </p:nvSpPr>
+        <p:spPr>
+          <a:xfrm>
+            <a:off x="5188077" y="2786849"/>
+            <a:ext cx="1815844" cy="369332"/>
+          </a:xfrm>
+          <a:prstGeom prst="rect">
+            <a:avLst/>
+          </a:prstGeom>
+          <a:noFill/>
+        </p:spPr>
+        <p:txBody>
+          <a:bodyPr wrap="square">
+            <a:spAutoFit/>
+          </a:bodyPr>
+          <a:lstStyle/>
+          <a:p>
+            <a:r>
+              <a:rPr lang="zh-CN" altLang="en-US" dirty="0">
+                <a:solidFill>
+                  <a:schemeClr val="accent1"/>
+                </a:solidFill>
+              </a:rPr>
+              <a:t>いんさつぶつ</a:t>
+            </a:r>
+          </a:p>
+        </p:txBody>
+      </p:sp>
+      <p:sp>
+        <p:nvSpPr>
+          <p:cNvPr id="24" name="文本框 23">
+            <a:extLst>
+              <a:ext uri="{FF2B5EF4-FFF2-40B4-BE49-F238E27FC236}">
+                <a16:creationId xmlns:a16="http://schemas.microsoft.com/office/drawing/2014/main" id="{9BE43667-38A6-4F6C-8BA3-CCB98331595F}"/>
+              </a:ext>
+            </a:extLst>
+          </p:cNvPr>
+          <p:cNvSpPr txBox="1"/>
+          <p:nvPr/>
+        </p:nvSpPr>
+        <p:spPr>
+          <a:xfrm>
+            <a:off x="8249311" y="2805590"/>
+            <a:ext cx="1586909" cy="369332"/>
+          </a:xfrm>
+          <a:prstGeom prst="rect">
+            <a:avLst/>
+          </a:prstGeom>
+          <a:noFill/>
+        </p:spPr>
+        <p:txBody>
+          <a:bodyPr wrap="square">
+            <a:spAutoFit/>
+          </a:bodyPr>
+          <a:lstStyle/>
+          <a:p>
+            <a:r>
+              <a:rPr lang="zh-CN" altLang="en-US" dirty="0">
+                <a:solidFill>
+                  <a:schemeClr val="accent1"/>
+                </a:solidFill>
+              </a:rPr>
+              <a:t>つかいかた</a:t>
+            </a:r>
+          </a:p>
+        </p:txBody>
+      </p:sp>
+      <p:sp>
+        <p:nvSpPr>
+          <p:cNvPr id="26" name="文本框 25">
+            <a:extLst>
+              <a:ext uri="{FF2B5EF4-FFF2-40B4-BE49-F238E27FC236}">
+                <a16:creationId xmlns:a16="http://schemas.microsoft.com/office/drawing/2014/main" id="{4A7D4BBE-5C2D-488C-886C-EF936D56F8C6}"/>
+              </a:ext>
+            </a:extLst>
+          </p:cNvPr>
+          <p:cNvSpPr txBox="1"/>
+          <p:nvPr/>
+        </p:nvSpPr>
+        <p:spPr>
+          <a:xfrm>
+            <a:off x="2666113" y="3677718"/>
+            <a:ext cx="1181543" cy="369332"/>
+          </a:xfrm>
+          <a:prstGeom prst="rect">
+            <a:avLst/>
+          </a:prstGeom>
+          <a:noFill/>
+        </p:spPr>
+        <p:txBody>
+          <a:bodyPr wrap="square">
+            <a:spAutoFit/>
+          </a:bodyPr>
+          <a:lstStyle/>
+          <a:p>
+            <a:r>
+              <a:rPr lang="zh-CN" altLang="en-US" dirty="0">
+                <a:solidFill>
+                  <a:schemeClr val="accent1"/>
+                </a:solidFill>
+              </a:rPr>
+              <a:t>もんだい</a:t>
+            </a:r>
+          </a:p>
+        </p:txBody>
+      </p:sp>
+      <p:sp>
+        <p:nvSpPr>
+          <p:cNvPr id="28" name="文本框 27">
+            <a:extLst>
+              <a:ext uri="{FF2B5EF4-FFF2-40B4-BE49-F238E27FC236}">
+                <a16:creationId xmlns:a16="http://schemas.microsoft.com/office/drawing/2014/main" id="{C5892AEE-44BE-481D-827B-FE767C79C75B}"/>
+              </a:ext>
+            </a:extLst>
+          </p:cNvPr>
+          <p:cNvSpPr txBox="1"/>
+          <p:nvPr/>
+        </p:nvSpPr>
+        <p:spPr>
+          <a:xfrm>
+            <a:off x="5621965" y="3672101"/>
+            <a:ext cx="672509" cy="369332"/>
+          </a:xfrm>
+          <a:prstGeom prst="rect">
+            <a:avLst/>
+          </a:prstGeom>
+          <a:noFill/>
+        </p:spPr>
+        <p:txBody>
+          <a:bodyPr wrap="square">
+            <a:spAutoFit/>
+          </a:bodyPr>
+          <a:lstStyle/>
+          <a:p>
+            <a:r>
+              <a:rPr lang="zh-CN" altLang="en-US" dirty="0">
+                <a:solidFill>
+                  <a:schemeClr val="accent1"/>
+                </a:solidFill>
+              </a:rPr>
+              <a:t>もじ</a:t>
+            </a:r>
+          </a:p>
+        </p:txBody>
+      </p:sp>
+      <p:sp>
+        <p:nvSpPr>
+          <p:cNvPr id="30" name="文本框 29">
+            <a:extLst>
+              <a:ext uri="{FF2B5EF4-FFF2-40B4-BE49-F238E27FC236}">
+                <a16:creationId xmlns:a16="http://schemas.microsoft.com/office/drawing/2014/main" id="{1944DEEC-BEC8-4DAA-94B5-F6EF3C222CED}"/>
+              </a:ext>
+            </a:extLst>
+          </p:cNvPr>
+          <p:cNvSpPr txBox="1"/>
+          <p:nvPr/>
+        </p:nvSpPr>
+        <p:spPr>
+          <a:xfrm>
+            <a:off x="1964365" y="4519009"/>
+            <a:ext cx="701748" cy="369332"/>
+          </a:xfrm>
+          <a:prstGeom prst="rect">
+            <a:avLst/>
+          </a:prstGeom>
+          <a:noFill/>
+        </p:spPr>
+        <p:txBody>
+          <a:bodyPr wrap="square">
+            <a:spAutoFit/>
+          </a:bodyPr>
+          <a:lstStyle/>
+          <a:p>
+            <a:r>
+              <a:rPr lang="zh-CN" altLang="en-US" dirty="0">
+                <a:solidFill>
+                  <a:schemeClr val="accent1"/>
+                </a:solidFill>
+              </a:rPr>
+              <a:t>え</a:t>
+            </a:r>
+          </a:p>
+        </p:txBody>
+      </p:sp>
+      <p:sp>
+        <p:nvSpPr>
+          <p:cNvPr id="32" name="文本框 31">
+            <a:extLst>
+              <a:ext uri="{FF2B5EF4-FFF2-40B4-BE49-F238E27FC236}">
+                <a16:creationId xmlns:a16="http://schemas.microsoft.com/office/drawing/2014/main" id="{636EC66D-1682-4FFB-B09D-C50ED9B0E11A}"/>
+              </a:ext>
+            </a:extLst>
+          </p:cNvPr>
+          <p:cNvSpPr txBox="1"/>
+          <p:nvPr/>
+        </p:nvSpPr>
+        <p:spPr>
+          <a:xfrm>
+            <a:off x="4129863" y="4528238"/>
+            <a:ext cx="1133253" cy="369332"/>
+          </a:xfrm>
+          <a:prstGeom prst="rect">
+            <a:avLst/>
+          </a:prstGeom>
+          <a:noFill/>
+        </p:spPr>
+        <p:txBody>
+          <a:bodyPr wrap="square">
+            <a:spAutoFit/>
+          </a:bodyPr>
+          <a:lstStyle/>
+          <a:p>
+            <a:r>
+              <a:rPr lang="zh-CN" altLang="en-US" dirty="0">
+                <a:solidFill>
+                  <a:schemeClr val="accent1"/>
+                </a:solidFill>
+              </a:rPr>
+              <a:t>かんけつ</a:t>
+            </a:r>
+          </a:p>
+        </p:txBody>
+      </p:sp>
+      <p:sp>
+        <p:nvSpPr>
+          <p:cNvPr id="34" name="文本框 33">
+            <a:extLst>
+              <a:ext uri="{FF2B5EF4-FFF2-40B4-BE49-F238E27FC236}">
+                <a16:creationId xmlns:a16="http://schemas.microsoft.com/office/drawing/2014/main" id="{2254E6F3-790B-4A1D-9C01-76F2146B86DC}"/>
+              </a:ext>
+            </a:extLst>
+          </p:cNvPr>
+          <p:cNvSpPr txBox="1"/>
+          <p:nvPr/>
+        </p:nvSpPr>
+        <p:spPr>
+          <a:xfrm>
+            <a:off x="5015910" y="4990107"/>
+            <a:ext cx="895792" cy="369332"/>
+          </a:xfrm>
+          <a:prstGeom prst="rect">
+            <a:avLst/>
+          </a:prstGeom>
+          <a:noFill/>
+        </p:spPr>
+        <p:txBody>
+          <a:bodyPr wrap="square">
+            <a:spAutoFit/>
+          </a:bodyPr>
+          <a:lstStyle/>
+          <a:p>
+            <a:r>
+              <a:rPr lang="zh-CN" altLang="en-US" dirty="0">
+                <a:solidFill>
+                  <a:schemeClr val="accent1"/>
+                </a:solidFill>
+              </a:rPr>
+              <a:t>どうが</a:t>
+            </a:r>
+          </a:p>
+        </p:txBody>
+      </p:sp>
+      <p:sp>
+        <p:nvSpPr>
+          <p:cNvPr id="36" name="文本框 35">
+            <a:extLst>
+              <a:ext uri="{FF2B5EF4-FFF2-40B4-BE49-F238E27FC236}">
+                <a16:creationId xmlns:a16="http://schemas.microsoft.com/office/drawing/2014/main" id="{7FE74E20-9227-49E8-834A-2FF80E7EE9A4}"/>
+              </a:ext>
+            </a:extLst>
+          </p:cNvPr>
+          <p:cNvSpPr txBox="1"/>
+          <p:nvPr/>
+        </p:nvSpPr>
+        <p:spPr>
+          <a:xfrm>
+            <a:off x="5621965" y="4557353"/>
+            <a:ext cx="1381956" cy="369332"/>
+          </a:xfrm>
+          <a:prstGeom prst="rect">
+            <a:avLst/>
+          </a:prstGeom>
+          <a:noFill/>
+        </p:spPr>
+        <p:txBody>
+          <a:bodyPr wrap="square">
+            <a:spAutoFit/>
+          </a:bodyPr>
+          <a:lstStyle/>
+          <a:p>
+            <a:r>
+              <a:rPr lang="zh-CN" altLang="en-US" dirty="0">
+                <a:solidFill>
+                  <a:schemeClr val="accent1"/>
+                </a:solidFill>
+              </a:rPr>
+              <a:t>せんざい</a:t>
+            </a:r>
+          </a:p>
+        </p:txBody>
+      </p:sp>
+      <p:sp>
+        <p:nvSpPr>
+          <p:cNvPr id="38" name="文本框 37">
+            <a:extLst>
+              <a:ext uri="{FF2B5EF4-FFF2-40B4-BE49-F238E27FC236}">
+                <a16:creationId xmlns:a16="http://schemas.microsoft.com/office/drawing/2014/main" id="{97C0F70B-5F4E-436B-B767-06E944149DC7}"/>
+              </a:ext>
+            </a:extLst>
+          </p:cNvPr>
+          <p:cNvSpPr txBox="1"/>
+          <p:nvPr/>
+        </p:nvSpPr>
+        <p:spPr>
+          <a:xfrm>
+            <a:off x="999350" y="5436230"/>
+            <a:ext cx="1036785" cy="369332"/>
+          </a:xfrm>
+          <a:prstGeom prst="rect">
+            <a:avLst/>
+          </a:prstGeom>
+          <a:noFill/>
+        </p:spPr>
+        <p:txBody>
+          <a:bodyPr wrap="square">
+            <a:spAutoFit/>
+          </a:bodyPr>
+          <a:lstStyle/>
+          <a:p>
+            <a:r>
+              <a:rPr lang="zh-CN" altLang="en-US" dirty="0">
+                <a:solidFill>
+                  <a:schemeClr val="accent1"/>
+                </a:solidFill>
+              </a:rPr>
+              <a:t>よけい</a:t>
+            </a:r>
+          </a:p>
+        </p:txBody>
+      </p:sp>
+      <p:sp>
+        <p:nvSpPr>
+          <p:cNvPr id="40" name="文本框 39">
+            <a:extLst>
+              <a:ext uri="{FF2B5EF4-FFF2-40B4-BE49-F238E27FC236}">
+                <a16:creationId xmlns:a16="http://schemas.microsoft.com/office/drawing/2014/main" id="{4D9CE317-CB99-4A1C-9017-5AFD8C93428E}"/>
+              </a:ext>
+            </a:extLst>
+          </p:cNvPr>
+          <p:cNvSpPr txBox="1"/>
+          <p:nvPr/>
+        </p:nvSpPr>
+        <p:spPr>
+          <a:xfrm>
+            <a:off x="2218657" y="5424294"/>
+            <a:ext cx="753033" cy="369332"/>
+          </a:xfrm>
+          <a:prstGeom prst="rect">
+            <a:avLst/>
+          </a:prstGeom>
+          <a:noFill/>
+        </p:spPr>
+        <p:txBody>
+          <a:bodyPr wrap="square">
+            <a:spAutoFit/>
+          </a:bodyPr>
+          <a:lstStyle/>
+          <a:p>
+            <a:r>
+              <a:rPr lang="zh-CN" altLang="en-US" dirty="0">
+                <a:solidFill>
+                  <a:schemeClr val="accent1"/>
+                </a:solidFill>
+              </a:rPr>
+              <a:t>はぶ</a:t>
+            </a:r>
+          </a:p>
+        </p:txBody>
+      </p:sp>
+      <p:sp>
+        <p:nvSpPr>
+          <p:cNvPr id="42" name="文本框 41">
+            <a:extLst>
+              <a:ext uri="{FF2B5EF4-FFF2-40B4-BE49-F238E27FC236}">
+                <a16:creationId xmlns:a16="http://schemas.microsoft.com/office/drawing/2014/main" id="{41369422-39C7-49EF-AFD0-51D19A7CEE42}"/>
+              </a:ext>
+            </a:extLst>
+          </p:cNvPr>
+          <p:cNvSpPr txBox="1"/>
+          <p:nvPr/>
+        </p:nvSpPr>
+        <p:spPr>
+          <a:xfrm>
+            <a:off x="6030432" y="5397412"/>
+            <a:ext cx="973489" cy="369332"/>
+          </a:xfrm>
+          <a:prstGeom prst="rect">
+            <a:avLst/>
+          </a:prstGeom>
+          <a:noFill/>
+        </p:spPr>
+        <p:txBody>
+          <a:bodyPr wrap="square">
+            <a:spAutoFit/>
+          </a:bodyPr>
+          <a:lstStyle/>
+          <a:p>
+            <a:r>
+              <a:rPr lang="zh-CN" altLang="en-US" dirty="0">
+                <a:solidFill>
+                  <a:schemeClr val="accent1"/>
+                </a:solidFill>
+              </a:rPr>
+              <a:t>じまく</a:t>
+            </a:r>
+          </a:p>
+        </p:txBody>
+      </p:sp>
+      <p:sp>
+        <p:nvSpPr>
+          <p:cNvPr id="44" name="文本框 43">
+            <a:extLst>
+              <a:ext uri="{FF2B5EF4-FFF2-40B4-BE49-F238E27FC236}">
+                <a16:creationId xmlns:a16="http://schemas.microsoft.com/office/drawing/2014/main" id="{B7B0F7FF-BE8E-451F-BB4D-A6C27E01B650}"/>
+              </a:ext>
+            </a:extLst>
+          </p:cNvPr>
+          <p:cNvSpPr txBox="1"/>
+          <p:nvPr/>
+        </p:nvSpPr>
+        <p:spPr>
+          <a:xfrm>
+            <a:off x="6465509" y="5836603"/>
+            <a:ext cx="1381956" cy="369332"/>
+          </a:xfrm>
+          <a:prstGeom prst="rect">
+            <a:avLst/>
+          </a:prstGeom>
+          <a:noFill/>
+        </p:spPr>
+        <p:txBody>
+          <a:bodyPr wrap="square">
+            <a:spAutoFit/>
+          </a:bodyPr>
+          <a:lstStyle/>
+          <a:p>
+            <a:r>
+              <a:rPr lang="zh-CN" altLang="en-US" dirty="0">
+                <a:solidFill>
+                  <a:schemeClr val="accent1"/>
+                </a:solidFill>
+              </a:rPr>
+              <a:t>ふくすう</a:t>
+            </a:r>
+          </a:p>
+        </p:txBody>
+      </p:sp>
+      <p:sp>
+        <p:nvSpPr>
+          <p:cNvPr id="46" name="文本框 45">
+            <a:extLst>
+              <a:ext uri="{FF2B5EF4-FFF2-40B4-BE49-F238E27FC236}">
+                <a16:creationId xmlns:a16="http://schemas.microsoft.com/office/drawing/2014/main" id="{0CED641B-2A5E-4D6C-AAFB-A34E50F6C3F8}"/>
+              </a:ext>
+            </a:extLst>
+          </p:cNvPr>
+          <p:cNvSpPr txBox="1"/>
+          <p:nvPr/>
+        </p:nvSpPr>
+        <p:spPr>
+          <a:xfrm>
+            <a:off x="7003921" y="5424294"/>
+            <a:ext cx="998851" cy="369332"/>
+          </a:xfrm>
+          <a:prstGeom prst="rect">
+            <a:avLst/>
+          </a:prstGeom>
+          <a:noFill/>
+        </p:spPr>
+        <p:txBody>
+          <a:bodyPr wrap="square">
+            <a:spAutoFit/>
+          </a:bodyPr>
+          <a:lstStyle/>
+          <a:p>
+            <a:r>
+              <a:rPr lang="zh-CN" altLang="en-US" dirty="0">
+                <a:solidFill>
+                  <a:schemeClr val="accent1"/>
+                </a:solidFill>
+              </a:rPr>
+              <a:t>げんご</a:t>
+            </a:r>
+          </a:p>
+        </p:txBody>
+      </p:sp>
+      <p:sp>
+        <p:nvSpPr>
+          <p:cNvPr id="48" name="文本框 47">
+            <a:extLst>
+              <a:ext uri="{FF2B5EF4-FFF2-40B4-BE49-F238E27FC236}">
+                <a16:creationId xmlns:a16="http://schemas.microsoft.com/office/drawing/2014/main" id="{7855018D-6E0A-4AB8-AA01-2AAF00C1BEEE}"/>
+              </a:ext>
+            </a:extLst>
+          </p:cNvPr>
+          <p:cNvSpPr txBox="1"/>
+          <p:nvPr/>
+        </p:nvSpPr>
+        <p:spPr>
+          <a:xfrm>
+            <a:off x="7503346" y="5863485"/>
+            <a:ext cx="1211611" cy="369332"/>
+          </a:xfrm>
+          <a:prstGeom prst="rect">
+            <a:avLst/>
+          </a:prstGeom>
+          <a:noFill/>
+        </p:spPr>
+        <p:txBody>
+          <a:bodyPr wrap="square">
+            <a:spAutoFit/>
+          </a:bodyPr>
+          <a:lstStyle/>
+          <a:p>
+            <a:r>
+              <a:rPr lang="zh-CN" altLang="en-US" dirty="0">
+                <a:solidFill>
+                  <a:schemeClr val="accent1"/>
+                </a:solidFill>
+              </a:rPr>
+              <a:t>たいおう</a:t>
+            </a:r>
+          </a:p>
+        </p:txBody>
+      </p:sp>
+    </p:spTree>
+    <p:extLst>
+      <p:ext uri="{BB962C8B-B14F-4D97-AF65-F5344CB8AC3E}">
+        <p14:creationId xmlns:p14="http://schemas.microsoft.com/office/powerpoint/2010/main" val="2733030763"/>
       </p:ext>
     </p:extLst>
   </p:cSld>

</xml_diff>